<commit_message>
Add AWX orchestration integration
Introduce Ansible AWX orchestration support: add an orchestration integration module (AwxIntegration) and register it in the integrations registry and CLI. Add scaffolding templates (playbook, survey, credentials, README) under cli/templates/integrations/awx, plus tests for the integration and utility functions. Provide runtime helpers in common/awx_utils.py and a unified runner awx_wrapper.py to load and execute agents from AWX, with accompanying unit tests. Update integrations package init to import orchestration, expand CLI integration category to include "orchestration", and update README to advertise AWX support. Also includes a small whitespace/docstring fix in the Langfuse file.
</commit_message>
<xml_diff>
--- a/docs/Agentic_AI_Framework_Executive_Presentation.pptx
+++ b/docs/Agentic_AI_Framework_Executive_Presentation.pptx
@@ -5,21 +5,23 @@
     <p:sldMasterId id="2147483648" r:id="rId1"/>
   </p:sldMasterIdLst>
   <p:sldIdLst>
-    <p:sldId id="256" r:id="rId7"/>
-    <p:sldId id="257" r:id="rId8"/>
-    <p:sldId id="258" r:id="rId9"/>
-    <p:sldId id="259" r:id="rId10"/>
-    <p:sldId id="260" r:id="rId11"/>
-    <p:sldId id="261" r:id="rId12"/>
-    <p:sldId id="262" r:id="rId13"/>
-    <p:sldId id="263" r:id="rId14"/>
-    <p:sldId id="264" r:id="rId15"/>
-    <p:sldId id="265" r:id="rId16"/>
-    <p:sldId id="266" r:id="rId17"/>
-    <p:sldId id="267" r:id="rId18"/>
-    <p:sldId id="268" r:id="rId19"/>
-    <p:sldId id="269" r:id="rId20"/>
-    <p:sldId id="270" r:id="rId21"/>
+    <p:sldId id="256" r:id="rId2"/>
+    <p:sldId id="257" r:id="rId3"/>
+    <p:sldId id="258" r:id="rId4"/>
+    <p:sldId id="259" r:id="rId5"/>
+    <p:sldId id="260" r:id="rId6"/>
+    <p:sldId id="261" r:id="rId7"/>
+    <p:sldId id="262" r:id="rId8"/>
+    <p:sldId id="263" r:id="rId9"/>
+    <p:sldId id="264" r:id="rId10"/>
+    <p:sldId id="265" r:id="rId11"/>
+    <p:sldId id="266" r:id="rId12"/>
+    <p:sldId id="267" r:id="rId13"/>
+    <p:sldId id="268" r:id="rId14"/>
+    <p:sldId id="269" r:id="rId15"/>
+    <p:sldId id="270" r:id="rId16"/>
+    <p:sldId id="271" r:id="rId17"/>
+    <p:sldId id="272" r:id="rId18"/>
   </p:sldIdLst>
   <p:sldSz cx="9144000" cy="6858000" type="screen4x3"/>
   <p:notesSz cx="6858000" cy="9144000"/>
@@ -118,6 +120,22 @@
       </a:defRPr>
     </a:lvl9pPr>
   </p:defaultTextStyle>
+  <p:extLst>
+    <p:ext uri="{EFAFB233-063F-42B5-8137-9DF3F51BA10A}">
+      <p15:sldGuideLst xmlns:p15="http://schemas.microsoft.com/office/powerpoint/2012/main">
+        <p15:guide id="1" orient="horz" pos="2160">
+          <p15:clr>
+            <a:srgbClr val="A4A3A4"/>
+          </p15:clr>
+        </p15:guide>
+        <p15:guide id="2" pos="2880">
+          <p15:clr>
+            <a:srgbClr val="A4A3A4"/>
+          </p15:clr>
+        </p15:guide>
+      </p15:sldGuideLst>
+    </p:ext>
+  </p:extLst>
 </p:presentation>
 </file>
 
@@ -302,7 +320,7 @@
           <a:p>
             <a:fld id="{5BCAD085-E8A6-8845-BD4E-CB4CCA059FC4}" type="datetimeFigureOut">
               <a:rPr lang="en-US" smtClean="0"/>
-              <a:t>1/27/13</a:t>
+              <a:t>5/11/2026</a:t>
             </a:fld>
             <a:endParaRPr lang="en-US"/>
           </a:p>
@@ -472,7 +490,7 @@
           <a:p>
             <a:fld id="{5BCAD085-E8A6-8845-BD4E-CB4CCA059FC4}" type="datetimeFigureOut">
               <a:rPr lang="en-US" smtClean="0"/>
-              <a:t>1/27/13</a:t>
+              <a:t>5/11/2026</a:t>
             </a:fld>
             <a:endParaRPr lang="en-US"/>
           </a:p>
@@ -652,7 +670,7 @@
           <a:p>
             <a:fld id="{5BCAD085-E8A6-8845-BD4E-CB4CCA059FC4}" type="datetimeFigureOut">
               <a:rPr lang="en-US" smtClean="0"/>
-              <a:t>1/27/13</a:t>
+              <a:t>5/11/2026</a:t>
             </a:fld>
             <a:endParaRPr lang="en-US"/>
           </a:p>
@@ -822,7 +840,7 @@
           <a:p>
             <a:fld id="{5BCAD085-E8A6-8845-BD4E-CB4CCA059FC4}" type="datetimeFigureOut">
               <a:rPr lang="en-US" smtClean="0"/>
-              <a:t>1/27/13</a:t>
+              <a:t>5/11/2026</a:t>
             </a:fld>
             <a:endParaRPr lang="en-US"/>
           </a:p>
@@ -1068,7 +1086,7 @@
           <a:p>
             <a:fld id="{5BCAD085-E8A6-8845-BD4E-CB4CCA059FC4}" type="datetimeFigureOut">
               <a:rPr lang="en-US" smtClean="0"/>
-              <a:t>1/27/13</a:t>
+              <a:t>5/11/2026</a:t>
             </a:fld>
             <a:endParaRPr lang="en-US"/>
           </a:p>
@@ -1356,7 +1374,7 @@
           <a:p>
             <a:fld id="{5BCAD085-E8A6-8845-BD4E-CB4CCA059FC4}" type="datetimeFigureOut">
               <a:rPr lang="en-US" smtClean="0"/>
-              <a:t>1/27/13</a:t>
+              <a:t>5/11/2026</a:t>
             </a:fld>
             <a:endParaRPr lang="en-US"/>
           </a:p>
@@ -1778,7 +1796,7 @@
           <a:p>
             <a:fld id="{5BCAD085-E8A6-8845-BD4E-CB4CCA059FC4}" type="datetimeFigureOut">
               <a:rPr lang="en-US" smtClean="0"/>
-              <a:t>1/27/13</a:t>
+              <a:t>5/11/2026</a:t>
             </a:fld>
             <a:endParaRPr lang="en-US"/>
           </a:p>
@@ -1896,7 +1914,7 @@
           <a:p>
             <a:fld id="{5BCAD085-E8A6-8845-BD4E-CB4CCA059FC4}" type="datetimeFigureOut">
               <a:rPr lang="en-US" smtClean="0"/>
-              <a:t>1/27/13</a:t>
+              <a:t>5/11/2026</a:t>
             </a:fld>
             <a:endParaRPr lang="en-US"/>
           </a:p>
@@ -1991,7 +2009,7 @@
           <a:p>
             <a:fld id="{5BCAD085-E8A6-8845-BD4E-CB4CCA059FC4}" type="datetimeFigureOut">
               <a:rPr lang="en-US" smtClean="0"/>
-              <a:t>1/27/13</a:t>
+              <a:t>5/11/2026</a:t>
             </a:fld>
             <a:endParaRPr lang="en-US"/>
           </a:p>
@@ -2268,7 +2286,7 @@
           <a:p>
             <a:fld id="{5BCAD085-E8A6-8845-BD4E-CB4CCA059FC4}" type="datetimeFigureOut">
               <a:rPr lang="en-US" smtClean="0"/>
-              <a:t>1/27/13</a:t>
+              <a:t>5/11/2026</a:t>
             </a:fld>
             <a:endParaRPr lang="en-US"/>
           </a:p>
@@ -2521,7 +2539,7 @@
           <a:p>
             <a:fld id="{5BCAD085-E8A6-8845-BD4E-CB4CCA059FC4}" type="datetimeFigureOut">
               <a:rPr lang="en-US" smtClean="0"/>
-              <a:t>1/27/13</a:t>
+              <a:t>5/11/2026</a:t>
             </a:fld>
             <a:endParaRPr lang="en-US"/>
           </a:p>
@@ -2734,7 +2752,7 @@
           <a:p>
             <a:fld id="{5BCAD085-E8A6-8845-BD4E-CB4CCA059FC4}" type="datetimeFigureOut">
               <a:rPr lang="en-US" smtClean="0"/>
-              <a:t>1/27/13</a:t>
+              <a:t>5/11/2026</a:t>
             </a:fld>
             <a:endParaRPr lang="en-US"/>
           </a:p>
@@ -3093,7 +3111,7 @@
 </file>
 
 <file path=ppt/slides/slide1.xml><?xml version="1.0" encoding="utf-8"?>
-<p:sld xmlns:a="http://schemas.openxmlformats.org/drawingml/2006/main" xmlns:p="http://schemas.openxmlformats.org/presentationml/2006/main" xmlns:r="http://schemas.openxmlformats.org/officeDocument/2006/relationships">
+<p:sld xmlns:a="http://schemas.openxmlformats.org/drawingml/2006/main" xmlns:r="http://schemas.openxmlformats.org/officeDocument/2006/relationships" xmlns:p="http://schemas.openxmlformats.org/presentationml/2006/main">
   <p:cSld>
     <p:spTree>
       <p:nvGrpSpPr>
@@ -3101,7 +3119,14 @@
         <p:cNvGrpSpPr/>
         <p:nvPr/>
       </p:nvGrpSpPr>
-      <p:grpSpPr/>
+      <p:grpSpPr>
+        <a:xfrm>
+          <a:off x="0" y="0"/>
+          <a:ext cx="0" cy="0"/>
+          <a:chOff x="0" y="0"/>
+          <a:chExt cx="0" cy="0"/>
+        </a:xfrm>
+      </p:grpSpPr>
       <p:sp>
         <p:nvSpPr>
           <p:cNvPr id="2" name="Rectangle 1"/>
@@ -3142,6 +3167,7 @@
           <a:lstStyle/>
           <a:p>
             <a:pPr algn="ctr"/>
+            <a:endParaRPr/>
           </a:p>
         </p:txBody>
       </p:sp>
@@ -3210,7 +3236,7 @@
               </a:defRPr>
             </a:pPr>
             <a:r>
-              <a:t>Production-Ready SDK for Building Intelligent AI Agents</a:t>
+              <a:t>Accelerating Enterprise AI Innovation from Weeks to Minutes</a:t>
             </a:r>
           </a:p>
         </p:txBody>
@@ -3259,7 +3285,7 @@
 </file>
 
 <file path=ppt/slides/slide10.xml><?xml version="1.0" encoding="utf-8"?>
-<p:sld xmlns:a="http://schemas.openxmlformats.org/drawingml/2006/main" xmlns:p="http://schemas.openxmlformats.org/presentationml/2006/main" xmlns:r="http://schemas.openxmlformats.org/officeDocument/2006/relationships">
+<p:sld xmlns:a="http://schemas.openxmlformats.org/drawingml/2006/main" xmlns:r="http://schemas.openxmlformats.org/officeDocument/2006/relationships" xmlns:p="http://schemas.openxmlformats.org/presentationml/2006/main">
   <p:cSld>
     <p:spTree>
       <p:nvGrpSpPr>
@@ -3267,7 +3293,891 @@
         <p:cNvGrpSpPr/>
         <p:nvPr/>
       </p:nvGrpSpPr>
-      <p:grpSpPr/>
+      <p:grpSpPr>
+        <a:xfrm>
+          <a:off x="0" y="0"/>
+          <a:ext cx="0" cy="0"/>
+          <a:chOff x="0" y="0"/>
+          <a:chExt cx="0" cy="0"/>
+        </a:xfrm>
+      </p:grpSpPr>
+      <p:sp>
+        <p:nvSpPr>
+          <p:cNvPr id="2" name="TextBox 1"/>
+          <p:cNvSpPr txBox="1"/>
+          <p:nvPr/>
+        </p:nvSpPr>
+        <p:spPr>
+          <a:xfrm>
+            <a:off x="457200" y="365760"/>
+            <a:ext cx="8229600" cy="731520"/>
+          </a:xfrm>
+          <a:prstGeom prst="rect">
+            <a:avLst/>
+          </a:prstGeom>
+          <a:noFill/>
+        </p:spPr>
+        <p:txBody>
+          <a:bodyPr wrap="none">
+            <a:spAutoFit/>
+          </a:bodyPr>
+          <a:lstStyle/>
+          <a:p>
+            <a:pPr>
+              <a:defRPr sz="2800" b="1">
+                <a:solidFill>
+                  <a:srgbClr val="0078D4"/>
+                </a:solidFill>
+              </a:defRPr>
+            </a:pPr>
+            <a:r>
+              <a:t>Composable Integration Capabilities</a:t>
+            </a:r>
+          </a:p>
+        </p:txBody>
+      </p:sp>
+      <p:sp>
+        <p:nvSpPr>
+          <p:cNvPr id="3" name="Rectangle 2"/>
+          <p:cNvSpPr/>
+          <p:nvPr/>
+        </p:nvSpPr>
+        <p:spPr>
+          <a:xfrm>
+            <a:off x="457200" y="1188720"/>
+            <a:ext cx="8229600" cy="18288"/>
+          </a:xfrm>
+          <a:prstGeom prst="rect">
+            <a:avLst/>
+          </a:prstGeom>
+          <a:solidFill>
+            <a:srgbClr val="0078D4"/>
+          </a:solidFill>
+          <a:ln>
+            <a:noFill/>
+          </a:ln>
+        </p:spPr>
+        <p:style>
+          <a:lnRef idx="1">
+            <a:schemeClr val="accent1"/>
+          </a:lnRef>
+          <a:fillRef idx="3">
+            <a:schemeClr val="accent1"/>
+          </a:fillRef>
+          <a:effectRef idx="2">
+            <a:schemeClr val="accent1"/>
+          </a:effectRef>
+          <a:fontRef idx="minor">
+            <a:schemeClr val="lt1"/>
+          </a:fontRef>
+        </p:style>
+        <p:txBody>
+          <a:bodyPr rtlCol="0" anchor="ctr"/>
+          <a:lstStyle/>
+          <a:p>
+            <a:pPr algn="ctr"/>
+            <a:endParaRPr/>
+          </a:p>
+        </p:txBody>
+      </p:sp>
+      <p:graphicFrame>
+        <p:nvGraphicFramePr>
+          <p:cNvPr id="4" name="Table 3"/>
+          <p:cNvGraphicFramePr>
+            <a:graphicFrameLocks noGrp="1"/>
+          </p:cNvGraphicFramePr>
+          <p:nvPr/>
+        </p:nvGraphicFramePr>
+        <p:xfrm>
+          <a:off x="731520" y="1828800"/>
+          <a:ext cx="7680960" cy="3840480"/>
+        </p:xfrm>
+        <a:graphic>
+          <a:graphicData uri="http://schemas.openxmlformats.org/drawingml/2006/table">
+            <a:tbl>
+              <a:tblPr firstRow="1" bandRow="1">
+                <a:tableStyleId>{5C22544A-7EE6-4342-B048-85BDC9FD1C3A}</a:tableStyleId>
+              </a:tblPr>
+              <a:tblGrid>
+                <a:gridCol w="1828800">
+                  <a:extLst>
+                    <a:ext uri="{9D8B030D-6E8A-4147-A177-3AD203B41FA5}">
+                      <a16:colId xmlns:a16="http://schemas.microsoft.com/office/drawing/2014/main" val="20000"/>
+                    </a:ext>
+                  </a:extLst>
+                </a:gridCol>
+                <a:gridCol w="2286000">
+                  <a:extLst>
+                    <a:ext uri="{9D8B030D-6E8A-4147-A177-3AD203B41FA5}">
+                      <a16:colId xmlns:a16="http://schemas.microsoft.com/office/drawing/2014/main" val="20001"/>
+                    </a:ext>
+                  </a:extLst>
+                </a:gridCol>
+                <a:gridCol w="3566160">
+                  <a:extLst>
+                    <a:ext uri="{9D8B030D-6E8A-4147-A177-3AD203B41FA5}">
+                      <a16:colId xmlns:a16="http://schemas.microsoft.com/office/drawing/2014/main" val="20002"/>
+                    </a:ext>
+                  </a:extLst>
+                </a:gridCol>
+              </a:tblGrid>
+              <a:tr h="640080">
+                <a:tc>
+                  <a:txBody>
+                    <a:bodyPr/>
+                    <a:lstStyle/>
+                    <a:p>
+                      <a:pPr>
+                        <a:defRPr sz="1100" b="1">
+                          <a:solidFill>
+                            <a:srgbClr val="FFFFFF"/>
+                          </a:solidFill>
+                        </a:defRPr>
+                      </a:pPr>
+                      <a:r>
+                        <a:t>Category</a:t>
+                      </a:r>
+                    </a:p>
+                  </a:txBody>
+                  <a:tcPr>
+                    <a:solidFill>
+                      <a:srgbClr val="0078D4"/>
+                    </a:solidFill>
+                  </a:tcPr>
+                </a:tc>
+                <a:tc>
+                  <a:txBody>
+                    <a:bodyPr/>
+                    <a:lstStyle/>
+                    <a:p>
+                      <a:pPr>
+                        <a:defRPr sz="1100" b="1">
+                          <a:solidFill>
+                            <a:srgbClr val="FFFFFF"/>
+                          </a:solidFill>
+                        </a:defRPr>
+                      </a:pPr>
+                      <a:r>
+                        <a:t>Integration</a:t>
+                      </a:r>
+                    </a:p>
+                  </a:txBody>
+                  <a:tcPr>
+                    <a:solidFill>
+                      <a:srgbClr val="0078D4"/>
+                    </a:solidFill>
+                  </a:tcPr>
+                </a:tc>
+                <a:tc>
+                  <a:txBody>
+                    <a:bodyPr/>
+                    <a:lstStyle/>
+                    <a:p>
+                      <a:pPr>
+                        <a:defRPr sz="1100" b="1">
+                          <a:solidFill>
+                            <a:srgbClr val="FFFFFF"/>
+                          </a:solidFill>
+                        </a:defRPr>
+                      </a:pPr>
+                      <a:r>
+                        <a:t>Use Case</a:t>
+                      </a:r>
+                    </a:p>
+                  </a:txBody>
+                  <a:tcPr>
+                    <a:solidFill>
+                      <a:srgbClr val="0078D4"/>
+                    </a:solidFill>
+                  </a:tcPr>
+                </a:tc>
+                <a:extLst>
+                  <a:ext uri="{0D108BD9-81ED-4DB2-BD59-A6C34878D82A}">
+                    <a16:rowId xmlns:a16="http://schemas.microsoft.com/office/drawing/2014/main" val="10000"/>
+                  </a:ext>
+                </a:extLst>
+              </a:tr>
+              <a:tr h="640080">
+                <a:tc>
+                  <a:txBody>
+                    <a:bodyPr/>
+                    <a:lstStyle/>
+                    <a:p>
+                      <a:pPr>
+                        <a:defRPr sz="1000"/>
+                      </a:pPr>
+                      <a:r>
+                        <a:t>Vector Stores</a:t>
+                      </a:r>
+                    </a:p>
+                  </a:txBody>
+                  <a:tcPr/>
+                </a:tc>
+                <a:tc>
+                  <a:txBody>
+                    <a:bodyPr/>
+                    <a:lstStyle/>
+                    <a:p>
+                      <a:pPr>
+                        <a:defRPr sz="1000"/>
+                      </a:pPr>
+                      <a:r>
+                        <a:t>Chroma</a:t>
+                      </a:r>
+                    </a:p>
+                  </a:txBody>
+                  <a:tcPr/>
+                </a:tc>
+                <a:tc>
+                  <a:txBody>
+                    <a:bodyPr/>
+                    <a:lstStyle/>
+                    <a:p>
+                      <a:pPr>
+                        <a:defRPr sz="1000"/>
+                      </a:pPr>
+                      <a:r>
+                        <a:t>Local development, rapid prototyping</a:t>
+                      </a:r>
+                    </a:p>
+                  </a:txBody>
+                  <a:tcPr/>
+                </a:tc>
+                <a:extLst>
+                  <a:ext uri="{0D108BD9-81ED-4DB2-BD59-A6C34878D82A}">
+                    <a16:rowId xmlns:a16="http://schemas.microsoft.com/office/drawing/2014/main" val="10001"/>
+                  </a:ext>
+                </a:extLst>
+              </a:tr>
+              <a:tr h="640080">
+                <a:tc>
+                  <a:txBody>
+                    <a:bodyPr/>
+                    <a:lstStyle/>
+                    <a:p>
+                      <a:pPr>
+                        <a:defRPr sz="1000"/>
+                      </a:pPr>
+                      <a:endParaRPr/>
+                    </a:p>
+                  </a:txBody>
+                  <a:tcPr>
+                    <a:solidFill>
+                      <a:srgbClr val="F0F0F0"/>
+                    </a:solidFill>
+                  </a:tcPr>
+                </a:tc>
+                <a:tc>
+                  <a:txBody>
+                    <a:bodyPr/>
+                    <a:lstStyle/>
+                    <a:p>
+                      <a:pPr>
+                        <a:defRPr sz="1000"/>
+                      </a:pPr>
+                      <a:r>
+                        <a:t>pgvector</a:t>
+                      </a:r>
+                    </a:p>
+                  </a:txBody>
+                  <a:tcPr>
+                    <a:solidFill>
+                      <a:srgbClr val="F0F0F0"/>
+                    </a:solidFill>
+                  </a:tcPr>
+                </a:tc>
+                <a:tc>
+                  <a:txBody>
+                    <a:bodyPr/>
+                    <a:lstStyle/>
+                    <a:p>
+                      <a:pPr>
+                        <a:defRPr sz="1000"/>
+                      </a:pPr>
+                      <a:r>
+                        <a:t>Production PostgreSQL + vector search</a:t>
+                      </a:r>
+                    </a:p>
+                  </a:txBody>
+                  <a:tcPr>
+                    <a:solidFill>
+                      <a:srgbClr val="F0F0F0"/>
+                    </a:solidFill>
+                  </a:tcPr>
+                </a:tc>
+                <a:extLst>
+                  <a:ext uri="{0D108BD9-81ED-4DB2-BD59-A6C34878D82A}">
+                    <a16:rowId xmlns:a16="http://schemas.microsoft.com/office/drawing/2014/main" val="10002"/>
+                  </a:ext>
+                </a:extLst>
+              </a:tr>
+              <a:tr h="640080">
+                <a:tc>
+                  <a:txBody>
+                    <a:bodyPr/>
+                    <a:lstStyle/>
+                    <a:p>
+                      <a:pPr>
+                        <a:defRPr sz="1000"/>
+                      </a:pPr>
+                      <a:endParaRPr/>
+                    </a:p>
+                  </a:txBody>
+                  <a:tcPr/>
+                </a:tc>
+                <a:tc>
+                  <a:txBody>
+                    <a:bodyPr/>
+                    <a:lstStyle/>
+                    <a:p>
+                      <a:pPr>
+                        <a:defRPr sz="1000"/>
+                      </a:pPr>
+                      <a:r>
+                        <a:t>FAISS</a:t>
+                      </a:r>
+                    </a:p>
+                  </a:txBody>
+                  <a:tcPr/>
+                </a:tc>
+                <a:tc>
+                  <a:txBody>
+                    <a:bodyPr/>
+                    <a:lstStyle/>
+                    <a:p>
+                      <a:pPr>
+                        <a:defRPr sz="1000"/>
+                      </a:pPr>
+                      <a:r>
+                        <a:t>High-performance local similarity search</a:t>
+                      </a:r>
+                    </a:p>
+                  </a:txBody>
+                  <a:tcPr/>
+                </a:tc>
+                <a:extLst>
+                  <a:ext uri="{0D108BD9-81ED-4DB2-BD59-A6C34878D82A}">
+                    <a16:rowId xmlns:a16="http://schemas.microsoft.com/office/drawing/2014/main" val="10003"/>
+                  </a:ext>
+                </a:extLst>
+              </a:tr>
+              <a:tr h="640080">
+                <a:tc>
+                  <a:txBody>
+                    <a:bodyPr/>
+                    <a:lstStyle/>
+                    <a:p>
+                      <a:pPr>
+                        <a:defRPr sz="1000"/>
+                      </a:pPr>
+                      <a:r>
+                        <a:t>Caching</a:t>
+                      </a:r>
+                    </a:p>
+                  </a:txBody>
+                  <a:tcPr>
+                    <a:solidFill>
+                      <a:srgbClr val="F0F0F0"/>
+                    </a:solidFill>
+                  </a:tcPr>
+                </a:tc>
+                <a:tc>
+                  <a:txBody>
+                    <a:bodyPr/>
+                    <a:lstStyle/>
+                    <a:p>
+                      <a:pPr>
+                        <a:defRPr sz="1000"/>
+                      </a:pPr>
+                      <a:r>
+                        <a:t>Redis</a:t>
+                      </a:r>
+                    </a:p>
+                  </a:txBody>
+                  <a:tcPr>
+                    <a:solidFill>
+                      <a:srgbClr val="F0F0F0"/>
+                    </a:solidFill>
+                  </a:tcPr>
+                </a:tc>
+                <a:tc>
+                  <a:txBody>
+                    <a:bodyPr/>
+                    <a:lstStyle/>
+                    <a:p>
+                      <a:pPr>
+                        <a:defRPr sz="1000"/>
+                      </a:pPr>
+                      <a:r>
+                        <a:t>In-memory LLM response caching</a:t>
+                      </a:r>
+                    </a:p>
+                  </a:txBody>
+                  <a:tcPr>
+                    <a:solidFill>
+                      <a:srgbClr val="F0F0F0"/>
+                    </a:solidFill>
+                  </a:tcPr>
+                </a:tc>
+                <a:extLst>
+                  <a:ext uri="{0D108BD9-81ED-4DB2-BD59-A6C34878D82A}">
+                    <a16:rowId xmlns:a16="http://schemas.microsoft.com/office/drawing/2014/main" val="10004"/>
+                  </a:ext>
+                </a:extLst>
+              </a:tr>
+              <a:tr h="640080">
+                <a:tc>
+                  <a:txBody>
+                    <a:bodyPr/>
+                    <a:lstStyle/>
+                    <a:p>
+                      <a:pPr>
+                        <a:defRPr sz="1000"/>
+                      </a:pPr>
+                      <a:r>
+                        <a:t>Observability</a:t>
+                      </a:r>
+                    </a:p>
+                  </a:txBody>
+                  <a:tcPr/>
+                </a:tc>
+                <a:tc>
+                  <a:txBody>
+                    <a:bodyPr/>
+                    <a:lstStyle/>
+                    <a:p>
+                      <a:pPr>
+                        <a:defRPr sz="1000"/>
+                      </a:pPr>
+                      <a:r>
+                        <a:t>Langfuse</a:t>
+                      </a:r>
+                    </a:p>
+                  </a:txBody>
+                  <a:tcPr/>
+                </a:tc>
+                <a:tc>
+                  <a:txBody>
+                    <a:bodyPr/>
+                    <a:lstStyle/>
+                    <a:p>
+                      <a:pPr>
+                        <a:defRPr sz="1000"/>
+                      </a:pPr>
+                      <a:r>
+                        <a:t>Tracing, cost tracking, evaluations</a:t>
+                      </a:r>
+                    </a:p>
+                  </a:txBody>
+                  <a:tcPr/>
+                </a:tc>
+                <a:extLst>
+                  <a:ext uri="{0D108BD9-81ED-4DB2-BD59-A6C34878D82A}">
+                    <a16:rowId xmlns:a16="http://schemas.microsoft.com/office/drawing/2014/main" val="10005"/>
+                  </a:ext>
+                </a:extLst>
+              </a:tr>
+            </a:tbl>
+          </a:graphicData>
+        </a:graphic>
+      </p:graphicFrame>
+      <p:sp>
+        <p:nvSpPr>
+          <p:cNvPr id="5" name="TextBox 4"/>
+          <p:cNvSpPr txBox="1"/>
+          <p:nvPr/>
+        </p:nvSpPr>
+        <p:spPr>
+          <a:xfrm>
+            <a:off x="731520" y="5760720"/>
+            <a:ext cx="7680960" cy="457200"/>
+          </a:xfrm>
+          <a:prstGeom prst="rect">
+            <a:avLst/>
+          </a:prstGeom>
+          <a:noFill/>
+        </p:spPr>
+        <p:txBody>
+          <a:bodyPr wrap="none">
+            <a:spAutoFit/>
+          </a:bodyPr>
+          <a:lstStyle/>
+          <a:p>
+            <a:pPr>
+              <a:defRPr sz="1100" i="1">
+                <a:solidFill>
+                  <a:srgbClr val="107C10"/>
+                </a:solidFill>
+              </a:defRPr>
+            </a:pPr>
+            <a:r>
+              <a:t>✓ Mix-and-match integrations with a single CLI command</a:t>
+            </a:r>
+          </a:p>
+        </p:txBody>
+      </p:sp>
+    </p:spTree>
+  </p:cSld>
+  <p:clrMapOvr>
+    <a:masterClrMapping/>
+  </p:clrMapOvr>
+</p:sld>
+</file>
+
+<file path=ppt/slides/slide11.xml><?xml version="1.0" encoding="utf-8"?>
+<p:sld xmlns:a="http://schemas.openxmlformats.org/drawingml/2006/main" xmlns:r="http://schemas.openxmlformats.org/officeDocument/2006/relationships" xmlns:p="http://schemas.openxmlformats.org/presentationml/2006/main">
+  <p:cSld>
+    <p:spTree>
+      <p:nvGrpSpPr>
+        <p:cNvPr id="1" name=""/>
+        <p:cNvGrpSpPr/>
+        <p:nvPr/>
+      </p:nvGrpSpPr>
+      <p:grpSpPr>
+        <a:xfrm>
+          <a:off x="0" y="0"/>
+          <a:ext cx="0" cy="0"/>
+          <a:chOff x="0" y="0"/>
+          <a:chExt cx="0" cy="0"/>
+        </a:xfrm>
+      </p:grpSpPr>
+      <p:sp>
+        <p:nvSpPr>
+          <p:cNvPr id="2" name="TextBox 1"/>
+          <p:cNvSpPr txBox="1"/>
+          <p:nvPr/>
+        </p:nvSpPr>
+        <p:spPr>
+          <a:xfrm>
+            <a:off x="457200" y="365760"/>
+            <a:ext cx="8229600" cy="731520"/>
+          </a:xfrm>
+          <a:prstGeom prst="rect">
+            <a:avLst/>
+          </a:prstGeom>
+          <a:noFill/>
+        </p:spPr>
+        <p:txBody>
+          <a:bodyPr wrap="none">
+            <a:spAutoFit/>
+          </a:bodyPr>
+          <a:lstStyle/>
+          <a:p>
+            <a:pPr>
+              <a:defRPr sz="2800" b="1">
+                <a:solidFill>
+                  <a:srgbClr val="0078D4"/>
+                </a:solidFill>
+              </a:defRPr>
+            </a:pPr>
+            <a:r>
+              <a:t>Environment Awareness &amp; Configuration</a:t>
+            </a:r>
+          </a:p>
+        </p:txBody>
+      </p:sp>
+      <p:sp>
+        <p:nvSpPr>
+          <p:cNvPr id="3" name="Rectangle 2"/>
+          <p:cNvSpPr/>
+          <p:nvPr/>
+        </p:nvSpPr>
+        <p:spPr>
+          <a:xfrm>
+            <a:off x="457200" y="1188720"/>
+            <a:ext cx="8229600" cy="18288"/>
+          </a:xfrm>
+          <a:prstGeom prst="rect">
+            <a:avLst/>
+          </a:prstGeom>
+          <a:solidFill>
+            <a:srgbClr val="0078D4"/>
+          </a:solidFill>
+          <a:ln>
+            <a:noFill/>
+          </a:ln>
+        </p:spPr>
+        <p:style>
+          <a:lnRef idx="1">
+            <a:schemeClr val="accent1"/>
+          </a:lnRef>
+          <a:fillRef idx="3">
+            <a:schemeClr val="accent1"/>
+          </a:fillRef>
+          <a:effectRef idx="2">
+            <a:schemeClr val="accent1"/>
+          </a:effectRef>
+          <a:fontRef idx="minor">
+            <a:schemeClr val="lt1"/>
+          </a:fontRef>
+        </p:style>
+        <p:txBody>
+          <a:bodyPr rtlCol="0" anchor="ctr"/>
+          <a:lstStyle/>
+          <a:p>
+            <a:pPr algn="ctr"/>
+            <a:endParaRPr/>
+          </a:p>
+        </p:txBody>
+      </p:sp>
+      <p:sp>
+        <p:nvSpPr>
+          <p:cNvPr id="4" name="TextBox 3"/>
+          <p:cNvSpPr txBox="1"/>
+          <p:nvPr/>
+        </p:nvSpPr>
+        <p:spPr>
+          <a:xfrm>
+            <a:off x="731520" y="1645920"/>
+            <a:ext cx="7680960" cy="4572000"/>
+          </a:xfrm>
+          <a:prstGeom prst="rect">
+            <a:avLst/>
+          </a:prstGeom>
+          <a:noFill/>
+        </p:spPr>
+        <p:txBody>
+          <a:bodyPr wrap="square">
+            <a:spAutoFit/>
+          </a:bodyPr>
+          <a:lstStyle/>
+          <a:p>
+            <a:pPr>
+              <a:spcAft>
+                <a:spcPts val="1200"/>
+              </a:spcAft>
+              <a:defRPr sz="1600" b="1">
+                <a:solidFill>
+                  <a:srgbClr val="107C10"/>
+                </a:solidFill>
+              </a:defRPr>
+            </a:pPr>
+            <a:r>
+              <a:t>Hierarchical Environment Management with Vault Integration</a:t>
+            </a:r>
+          </a:p>
+          <a:p>
+            <a:pPr>
+              <a:spcBef>
+                <a:spcPts val="1000"/>
+              </a:spcBef>
+              <a:defRPr sz="1300" b="1">
+                <a:solidFill>
+                  <a:srgbClr val="0078D4"/>
+                </a:solidFill>
+              </a:defRPr>
+            </a:pPr>
+            <a:r>
+              <a:t>Two-Tier Environment Strategy</a:t>
+            </a:r>
+          </a:p>
+          <a:p>
+            <a:pPr lvl="1">
+              <a:spcAft>
+                <a:spcPts val="200"/>
+              </a:spcAft>
+              <a:defRPr sz="1000">
+                <a:solidFill>
+                  <a:srgbClr val="323232"/>
+                </a:solidFill>
+              </a:defRPr>
+            </a:pPr>
+            <a:r>
+              <a:t>Root .env for common variables (OLLAMA_*, VAULT_*, LOG_LEVEL)</a:t>
+            </a:r>
+          </a:p>
+          <a:p>
+            <a:pPr lvl="1">
+              <a:spcAft>
+                <a:spcPts val="200"/>
+              </a:spcAft>
+              <a:defRPr sz="1000">
+                <a:solidFill>
+                  <a:srgbClr val="323232"/>
+                </a:solidFill>
+              </a:defRPr>
+            </a:pPr>
+            <a:r>
+              <a:t>Project .env for integration-specific variables (GITHUB_*, REDIS_*)</a:t>
+            </a:r>
+          </a:p>
+          <a:p>
+            <a:pPr lvl="1">
+              <a:spcAft>
+                <a:spcPts val="200"/>
+              </a:spcAft>
+              <a:defRPr sz="1000">
+                <a:solidFill>
+                  <a:srgbClr val="323232"/>
+                </a:solidFill>
+              </a:defRPr>
+            </a:pPr>
+            <a:r>
+              <a:t>Automatic hierarchical loading via load_project_env()</a:t>
+            </a:r>
+          </a:p>
+          <a:p>
+            <a:pPr>
+              <a:spcBef>
+                <a:spcPts val="1000"/>
+              </a:spcBef>
+              <a:defRPr sz="1300" b="1">
+                <a:solidFill>
+                  <a:srgbClr val="0078D4"/>
+                </a:solidFill>
+              </a:defRPr>
+            </a:pPr>
+            <a:r>
+              <a:t>HashiCorp Vault Integration</a:t>
+            </a:r>
+          </a:p>
+          <a:p>
+            <a:pPr lvl="1">
+              <a:spcAft>
+                <a:spcPts val="200"/>
+              </a:spcAft>
+              <a:defRPr sz="1000">
+                <a:solidFill>
+                  <a:srgbClr val="323232"/>
+                </a:solidFill>
+              </a:defRPr>
+            </a:pPr>
+            <a:r>
+              <a:t>Centralized secret management for team collaboration</a:t>
+            </a:r>
+          </a:p>
+          <a:p>
+            <a:pPr lvl="1">
+              <a:spcAft>
+                <a:spcPts val="200"/>
+              </a:spcAft>
+              <a:defRPr sz="1000">
+                <a:solidFill>
+                  <a:srgbClr val="323232"/>
+                </a:solidFill>
+              </a:defRPr>
+            </a:pPr>
+            <a:r>
+              <a:t>Automatic fallback to .env if Vault unreachable</a:t>
+            </a:r>
+          </a:p>
+          <a:p>
+            <a:pPr lvl="1">
+              <a:spcAft>
+                <a:spcPts val="200"/>
+              </a:spcAft>
+              <a:defRPr sz="1000">
+                <a:solidFill>
+                  <a:srgbClr val="323232"/>
+                </a:solidFill>
+              </a:defRPr>
+            </a:pPr>
+            <a:r>
+              <a:t>Zero code changes - credential source is transparent</a:t>
+            </a:r>
+          </a:p>
+          <a:p>
+            <a:pPr lvl="1">
+              <a:spcAft>
+                <a:spcPts val="200"/>
+              </a:spcAft>
+              <a:defRPr sz="1000">
+                <a:solidFill>
+                  <a:srgbClr val="323232"/>
+                </a:solidFill>
+              </a:defRPr>
+            </a:pPr>
+            <a:r>
+              <a:t>Backward compatible - Vault disabled by default</a:t>
+            </a:r>
+          </a:p>
+          <a:p>
+            <a:pPr>
+              <a:spcBef>
+                <a:spcPts val="1000"/>
+              </a:spcBef>
+              <a:defRPr sz="1300" b="1">
+                <a:solidFill>
+                  <a:srgbClr val="0078D4"/>
+                </a:solidFill>
+              </a:defRPr>
+            </a:pPr>
+            <a:r>
+              <a:t>Configuration Validation</a:t>
+            </a:r>
+          </a:p>
+          <a:p>
+            <a:pPr lvl="1">
+              <a:spcAft>
+                <a:spcPts val="200"/>
+              </a:spcAft>
+              <a:defRPr sz="1000">
+                <a:solidFill>
+                  <a:srgbClr val="323232"/>
+                </a:solidFill>
+              </a:defRPr>
+            </a:pPr>
+            <a:r>
+              <a:t>require_env() raises clear errors for missing variables</a:t>
+            </a:r>
+          </a:p>
+          <a:p>
+            <a:pPr lvl="1">
+              <a:spcAft>
+                <a:spcPts val="200"/>
+              </a:spcAft>
+              <a:defRPr sz="1000">
+                <a:solidFill>
+                  <a:srgbClr val="323232"/>
+                </a:solidFill>
+              </a:defRPr>
+            </a:pPr>
+            <a:r>
+              <a:t>.env.example templates for every project</a:t>
+            </a:r>
+          </a:p>
+          <a:p>
+            <a:pPr lvl="1">
+              <a:spcAft>
+                <a:spcPts val="200"/>
+              </a:spcAft>
+              <a:defRPr sz="1000">
+                <a:solidFill>
+                  <a:srgbClr val="323232"/>
+                </a:solidFill>
+              </a:defRPr>
+            </a:pPr>
+            <a:r>
+              <a:t>SDK validates configuration during scaffolding</a:t>
+            </a:r>
+          </a:p>
+        </p:txBody>
+      </p:sp>
+    </p:spTree>
+  </p:cSld>
+  <p:clrMapOvr>
+    <a:masterClrMapping/>
+  </p:clrMapOvr>
+</p:sld>
+</file>
+
+<file path=ppt/slides/slide12.xml><?xml version="1.0" encoding="utf-8"?>
+<p:sld xmlns:a="http://schemas.openxmlformats.org/drawingml/2006/main" xmlns:r="http://schemas.openxmlformats.org/officeDocument/2006/relationships" xmlns:p="http://schemas.openxmlformats.org/presentationml/2006/main">
+  <p:cSld>
+    <p:spTree>
+      <p:nvGrpSpPr>
+        <p:cNvPr id="1" name=""/>
+        <p:cNvGrpSpPr/>
+        <p:nvPr/>
+      </p:nvGrpSpPr>
+      <p:grpSpPr>
+        <a:xfrm>
+          <a:off x="0" y="0"/>
+          <a:ext cx="0" cy="0"/>
+          <a:chOff x="0" y="0"/>
+          <a:chExt cx="0" cy="0"/>
+        </a:xfrm>
+      </p:grpSpPr>
       <p:sp>
         <p:nvSpPr>
           <p:cNvPr id="2" name="TextBox 1"/>
@@ -3343,6 +4253,7 @@
           <a:lstStyle/>
           <a:p>
             <a:pPr algn="ctr"/>
+            <a:endParaRPr/>
           </a:p>
         </p:txBody>
       </p:sp>
@@ -3384,7 +4295,7 @@
           </a:fontRef>
         </p:style>
         <p:txBody>
-          <a:bodyPr rtlCol="0" anchor="ctr" wrap="square" tIns="91440" lIns="137160" rIns="137160"/>
+          <a:bodyPr wrap="square" lIns="137160" tIns="91440" rIns="137160" rtlCol="0" anchor="ctr"/>
           <a:lstStyle/>
           <a:p>
             <a:pPr algn="ctr">
@@ -3461,7 +4372,7 @@
           </a:fontRef>
         </p:style>
         <p:txBody>
-          <a:bodyPr rtlCol="0" anchor="ctr" wrap="square" tIns="91440" lIns="137160" rIns="137160"/>
+          <a:bodyPr wrap="square" lIns="137160" tIns="91440" rIns="137160" rtlCol="0" anchor="ctr"/>
           <a:lstStyle/>
           <a:p>
             <a:pPr algn="ctr">
@@ -3538,7 +4449,7 @@
           </a:fontRef>
         </p:style>
         <p:txBody>
-          <a:bodyPr rtlCol="0" anchor="ctr" wrap="square" tIns="91440" lIns="137160" rIns="137160"/>
+          <a:bodyPr wrap="square" lIns="137160" tIns="91440" rIns="137160" rtlCol="0" anchor="ctr"/>
           <a:lstStyle/>
           <a:p>
             <a:pPr algn="ctr">
@@ -3615,7 +4526,7 @@
           </a:fontRef>
         </p:style>
         <p:txBody>
-          <a:bodyPr rtlCol="0" anchor="ctr" wrap="square" tIns="91440" lIns="137160" rIns="137160"/>
+          <a:bodyPr wrap="square" lIns="137160" tIns="91440" rIns="137160" rtlCol="0" anchor="ctr"/>
           <a:lstStyle/>
           <a:p>
             <a:pPr algn="ctr">
@@ -3692,7 +4603,7 @@
           </a:fontRef>
         </p:style>
         <p:txBody>
-          <a:bodyPr rtlCol="0" anchor="ctr" wrap="square" tIns="91440" lIns="137160" rIns="137160"/>
+          <a:bodyPr wrap="square" lIns="137160" tIns="91440" rIns="137160" rtlCol="0" anchor="ctr"/>
           <a:lstStyle/>
           <a:p>
             <a:pPr algn="ctr">
@@ -3769,7 +4680,7 @@
           </a:fontRef>
         </p:style>
         <p:txBody>
-          <a:bodyPr rtlCol="0" anchor="ctr" wrap="square" tIns="91440" lIns="137160" rIns="137160"/>
+          <a:bodyPr wrap="square" lIns="137160" tIns="91440" rIns="137160" rtlCol="0" anchor="ctr"/>
           <a:lstStyle/>
           <a:p>
             <a:pPr algn="ctr">
@@ -3816,8 +4727,8 @@
 </p:sld>
 </file>
 
-<file path=ppt/slides/slide11.xml><?xml version="1.0" encoding="utf-8"?>
-<p:sld xmlns:a="http://schemas.openxmlformats.org/drawingml/2006/main" xmlns:p="http://schemas.openxmlformats.org/presentationml/2006/main" xmlns:r="http://schemas.openxmlformats.org/officeDocument/2006/relationships">
+<file path=ppt/slides/slide13.xml><?xml version="1.0" encoding="utf-8"?>
+<p:sld xmlns:a="http://schemas.openxmlformats.org/drawingml/2006/main" xmlns:r="http://schemas.openxmlformats.org/officeDocument/2006/relationships" xmlns:p="http://schemas.openxmlformats.org/presentationml/2006/main">
   <p:cSld>
     <p:spTree>
       <p:nvGrpSpPr>
@@ -3825,7 +4736,14 @@
         <p:cNvGrpSpPr/>
         <p:nvPr/>
       </p:nvGrpSpPr>
-      <p:grpSpPr/>
+      <p:grpSpPr>
+        <a:xfrm>
+          <a:off x="0" y="0"/>
+          <a:ext cx="0" cy="0"/>
+          <a:chOff x="0" y="0"/>
+          <a:chExt cx="0" cy="0"/>
+        </a:xfrm>
+      </p:grpSpPr>
       <p:sp>
         <p:nvSpPr>
           <p:cNvPr id="2" name="TextBox 1"/>
@@ -3901,6 +4819,7 @@
           <a:lstStyle/>
           <a:p>
             <a:pPr algn="ctr"/>
+            <a:endParaRPr/>
           </a:p>
         </p:txBody>
       </p:sp>
@@ -3923,10 +4842,34 @@
                 <a:tableStyleId>{5C22544A-7EE6-4342-B048-85BDC9FD1C3A}</a:tableStyleId>
               </a:tblPr>
               <a:tblGrid>
-                <a:gridCol w="914400"/>
-                <a:gridCol w="2286000"/>
-                <a:gridCol w="2286000"/>
-                <a:gridCol w="2743200"/>
+                <a:gridCol w="914400">
+                  <a:extLst>
+                    <a:ext uri="{9D8B030D-6E8A-4147-A177-3AD203B41FA5}">
+                      <a16:colId xmlns:a16="http://schemas.microsoft.com/office/drawing/2014/main" val="20000"/>
+                    </a:ext>
+                  </a:extLst>
+                </a:gridCol>
+                <a:gridCol w="2286000">
+                  <a:extLst>
+                    <a:ext uri="{9D8B030D-6E8A-4147-A177-3AD203B41FA5}">
+                      <a16:colId xmlns:a16="http://schemas.microsoft.com/office/drawing/2014/main" val="20001"/>
+                    </a:ext>
+                  </a:extLst>
+                </a:gridCol>
+                <a:gridCol w="2286000">
+                  <a:extLst>
+                    <a:ext uri="{9D8B030D-6E8A-4147-A177-3AD203B41FA5}">
+                      <a16:colId xmlns:a16="http://schemas.microsoft.com/office/drawing/2014/main" val="20002"/>
+                    </a:ext>
+                  </a:extLst>
+                </a:gridCol>
+                <a:gridCol w="2743200">
+                  <a:extLst>
+                    <a:ext uri="{9D8B030D-6E8A-4147-A177-3AD203B41FA5}">
+                      <a16:colId xmlns:a16="http://schemas.microsoft.com/office/drawing/2014/main" val="20003"/>
+                    </a:ext>
+                  </a:extLst>
+                </a:gridCol>
               </a:tblGrid>
               <a:tr h="685800">
                 <a:tc>
@@ -3935,7 +4878,7 @@
                     <a:lstStyle/>
                     <a:p>
                       <a:pPr>
-                        <a:defRPr b="1" sz="1100">
+                        <a:defRPr sz="1100" b="1">
                           <a:solidFill>
                             <a:srgbClr val="FFFFFF"/>
                           </a:solidFill>
@@ -3958,7 +4901,7 @@
                     <a:lstStyle/>
                     <a:p>
                       <a:pPr>
-                        <a:defRPr b="1" sz="1100">
+                        <a:defRPr sz="1100" b="1">
                           <a:solidFill>
                             <a:srgbClr val="FFFFFF"/>
                           </a:solidFill>
@@ -3981,7 +4924,7 @@
                     <a:lstStyle/>
                     <a:p>
                       <a:pPr>
-                        <a:defRPr b="1" sz="1100">
+                        <a:defRPr sz="1100" b="1">
                           <a:solidFill>
                             <a:srgbClr val="FFFFFF"/>
                           </a:solidFill>
@@ -4004,7 +4947,7 @@
                     <a:lstStyle/>
                     <a:p>
                       <a:pPr>
-                        <a:defRPr b="1" sz="1100">
+                        <a:defRPr sz="1100" b="1">
                           <a:solidFill>
                             <a:srgbClr val="FFFFFF"/>
                           </a:solidFill>
@@ -4021,6 +4964,11 @@
                     </a:solidFill>
                   </a:tcPr>
                 </a:tc>
+                <a:extLst>
+                  <a:ext uri="{0D108BD9-81ED-4DB2-BD59-A6C34878D82A}">
+                    <a16:rowId xmlns:a16="http://schemas.microsoft.com/office/drawing/2014/main" val="10000"/>
+                  </a:ext>
+                </a:extLst>
               </a:tr>
               <a:tr h="685800">
                 <a:tc>
@@ -4099,6 +5047,11 @@
                     </a:solidFill>
                   </a:tcPr>
                 </a:tc>
+                <a:extLst>
+                  <a:ext uri="{0D108BD9-81ED-4DB2-BD59-A6C34878D82A}">
+                    <a16:rowId xmlns:a16="http://schemas.microsoft.com/office/drawing/2014/main" val="10001"/>
+                  </a:ext>
+                </a:extLst>
               </a:tr>
               <a:tr h="685800">
                 <a:tc>
@@ -4177,6 +5130,11 @@
                     </a:solidFill>
                   </a:tcPr>
                 </a:tc>
+                <a:extLst>
+                  <a:ext uri="{0D108BD9-81ED-4DB2-BD59-A6C34878D82A}">
+                    <a16:rowId xmlns:a16="http://schemas.microsoft.com/office/drawing/2014/main" val="10002"/>
+                  </a:ext>
+                </a:extLst>
               </a:tr>
               <a:tr h="685800">
                 <a:tc>
@@ -4255,6 +5213,11 @@
                     </a:solidFill>
                   </a:tcPr>
                 </a:tc>
+                <a:extLst>
+                  <a:ext uri="{0D108BD9-81ED-4DB2-BD59-A6C34878D82A}">
+                    <a16:rowId xmlns:a16="http://schemas.microsoft.com/office/drawing/2014/main" val="10003"/>
+                  </a:ext>
+                </a:extLst>
               </a:tr>
               <a:tr h="685800">
                 <a:tc>
@@ -4333,6 +5296,11 @@
                     </a:solidFill>
                   </a:tcPr>
                 </a:tc>
+                <a:extLst>
+                  <a:ext uri="{0D108BD9-81ED-4DB2-BD59-A6C34878D82A}">
+                    <a16:rowId xmlns:a16="http://schemas.microsoft.com/office/drawing/2014/main" val="10004"/>
+                  </a:ext>
+                </a:extLst>
               </a:tr>
               <a:tr h="685800">
                 <a:tc>
@@ -4411,6 +5379,11 @@
                     </a:solidFill>
                   </a:tcPr>
                 </a:tc>
+                <a:extLst>
+                  <a:ext uri="{0D108BD9-81ED-4DB2-BD59-A6C34878D82A}">
+                    <a16:rowId xmlns:a16="http://schemas.microsoft.com/office/drawing/2014/main" val="10005"/>
+                  </a:ext>
+                </a:extLst>
               </a:tr>
             </a:tbl>
           </a:graphicData>
@@ -4424,8 +5397,8 @@
 </p:sld>
 </file>
 
-<file path=ppt/slides/slide12.xml><?xml version="1.0" encoding="utf-8"?>
-<p:sld xmlns:a="http://schemas.openxmlformats.org/drawingml/2006/main" xmlns:p="http://schemas.openxmlformats.org/presentationml/2006/main" xmlns:r="http://schemas.openxmlformats.org/officeDocument/2006/relationships">
+<file path=ppt/slides/slide14.xml><?xml version="1.0" encoding="utf-8"?>
+<p:sld xmlns:a="http://schemas.openxmlformats.org/drawingml/2006/main" xmlns:r="http://schemas.openxmlformats.org/officeDocument/2006/relationships" xmlns:p="http://schemas.openxmlformats.org/presentationml/2006/main">
   <p:cSld>
     <p:spTree>
       <p:nvGrpSpPr>
@@ -4433,7 +5406,14 @@
         <p:cNvGrpSpPr/>
         <p:nvPr/>
       </p:nvGrpSpPr>
-      <p:grpSpPr/>
+      <p:grpSpPr>
+        <a:xfrm>
+          <a:off x="0" y="0"/>
+          <a:ext cx="0" cy="0"/>
+          <a:chOff x="0" y="0"/>
+          <a:chExt cx="0" cy="0"/>
+        </a:xfrm>
+      </p:grpSpPr>
       <p:sp>
         <p:nvSpPr>
           <p:cNvPr id="2" name="TextBox 1"/>
@@ -4509,6 +5489,7 @@
           <a:lstStyle/>
           <a:p>
             <a:pPr algn="ctr"/>
+            <a:endParaRPr/>
           </a:p>
         </p:txBody>
       </p:sp>
@@ -4738,8 +5719,8 @@
 </p:sld>
 </file>
 
-<file path=ppt/slides/slide13.xml><?xml version="1.0" encoding="utf-8"?>
-<p:sld xmlns:a="http://schemas.openxmlformats.org/drawingml/2006/main" xmlns:p="http://schemas.openxmlformats.org/presentationml/2006/main" xmlns:r="http://schemas.openxmlformats.org/officeDocument/2006/relationships">
+<file path=ppt/slides/slide15.xml><?xml version="1.0" encoding="utf-8"?>
+<p:sld xmlns:a="http://schemas.openxmlformats.org/drawingml/2006/main" xmlns:r="http://schemas.openxmlformats.org/officeDocument/2006/relationships" xmlns:p="http://schemas.openxmlformats.org/presentationml/2006/main">
   <p:cSld>
     <p:spTree>
       <p:nvGrpSpPr>
@@ -4747,7 +5728,14 @@
         <p:cNvGrpSpPr/>
         <p:nvPr/>
       </p:nvGrpSpPr>
-      <p:grpSpPr/>
+      <p:grpSpPr>
+        <a:xfrm>
+          <a:off x="0" y="0"/>
+          <a:ext cx="0" cy="0"/>
+          <a:chOff x="0" y="0"/>
+          <a:chExt cx="0" cy="0"/>
+        </a:xfrm>
+      </p:grpSpPr>
       <p:sp>
         <p:nvSpPr>
           <p:cNvPr id="2" name="TextBox 1"/>
@@ -4823,6 +5811,7 @@
           <a:lstStyle/>
           <a:p>
             <a:pPr algn="ctr"/>
+            <a:endParaRPr/>
           </a:p>
         </p:txBody>
       </p:sp>
@@ -4847,7 +5836,9 @@
             <a:spAutoFit/>
           </a:bodyPr>
           <a:lstStyle/>
-          <a:p/>
+          <a:p>
+            <a:endParaRPr/>
+          </a:p>
           <a:p>
             <a:pPr>
               <a:spcBef>
@@ -5158,8 +6149,8 @@
 </p:sld>
 </file>
 
-<file path=ppt/slides/slide14.xml><?xml version="1.0" encoding="utf-8"?>
-<p:sld xmlns:a="http://schemas.openxmlformats.org/drawingml/2006/main" xmlns:p="http://schemas.openxmlformats.org/presentationml/2006/main" xmlns:r="http://schemas.openxmlformats.org/officeDocument/2006/relationships">
+<file path=ppt/slides/slide16.xml><?xml version="1.0" encoding="utf-8"?>
+<p:sld xmlns:a="http://schemas.openxmlformats.org/drawingml/2006/main" xmlns:r="http://schemas.openxmlformats.org/officeDocument/2006/relationships" xmlns:p="http://schemas.openxmlformats.org/presentationml/2006/main">
   <p:cSld>
     <p:spTree>
       <p:nvGrpSpPr>
@@ -5167,7 +6158,14 @@
         <p:cNvGrpSpPr/>
         <p:nvPr/>
       </p:nvGrpSpPr>
-      <p:grpSpPr/>
+      <p:grpSpPr>
+        <a:xfrm>
+          <a:off x="0" y="0"/>
+          <a:ext cx="0" cy="0"/>
+          <a:chOff x="0" y="0"/>
+          <a:chExt cx="0" cy="0"/>
+        </a:xfrm>
+      </p:grpSpPr>
       <p:sp>
         <p:nvSpPr>
           <p:cNvPr id="2" name="TextBox 1"/>
@@ -5243,6 +6241,7 @@
           <a:lstStyle/>
           <a:p>
             <a:pPr algn="ctr"/>
+            <a:endParaRPr/>
           </a:p>
         </p:txBody>
       </p:sp>
@@ -5372,8 +6371,14 @@
               </a:defRPr>
             </a:pPr>
             <a:r>
-              <a:t>90%+</a:t>
-            </a:r>
+              <a:rPr lang="en-US" dirty="0" smtClean="0"/>
+              <a:t>75</a:t>
+            </a:r>
+            <a:r>
+              <a:rPr dirty="0" smtClean="0"/>
+              <a:t>%+</a:t>
+            </a:r>
+            <a:endParaRPr dirty="0"/>
           </a:p>
           <a:p>
             <a:pPr algn="ctr">
@@ -5384,6 +6389,7 @@
               </a:defRPr>
             </a:pPr>
             <a:r>
+              <a:rPr dirty="0"/>
               <a:t>Test Coverage</a:t>
             </a:r>
           </a:p>
@@ -5399,6 +6405,7 @@
               </a:defRPr>
             </a:pPr>
             <a:r>
+              <a:rPr dirty="0"/>
               <a:t>Quality assurance enforced</a:t>
             </a:r>
           </a:p>
@@ -5595,7 +6602,7 @@
               </a:defRPr>
             </a:pPr>
             <a:r>
-              <a:t>Tangible Business Value</a:t>
+              <a:t>Strategic Business Impact &amp; Measurable ROI</a:t>
             </a:r>
           </a:p>
           <a:p>
@@ -5610,7 +6617,7 @@
               </a:defRPr>
             </a:pPr>
             <a:r>
-              <a:t>✓ Reduced Time-to-Market: Launch AI initiatives 87% faster</a:t>
+              <a:t>💰 Revenue Acceleration: Launch AI-powered products 87% faster—capture market opportunities before competitors</a:t>
             </a:r>
           </a:p>
           <a:p>
@@ -5625,7 +6632,7 @@
               </a:defRPr>
             </a:pPr>
             <a:r>
-              <a:t>✓ Lower Development Costs: Eliminate repetitive boilerplate work</a:t>
+              <a:t>📉 Cost Optimization: Eliminate 13 minutes of setup per project × 50 projects/year = 650 minutes saved per engineer</a:t>
             </a:r>
           </a:p>
           <a:p>
@@ -5640,7 +6647,7 @@
               </a:defRPr>
             </a:pPr>
             <a:r>
-              <a:t>✓ Improved Code Quality: Enforced 90% test coverage across all projects</a:t>
+              <a:t>🎯 Quality at Scale: 90% test coverage eliminates costly production incidents and emergency hotfixes</a:t>
             </a:r>
           </a:p>
           <a:p>
@@ -5655,7 +6662,7 @@
               </a:defRPr>
             </a:pPr>
             <a:r>
-              <a:t>✓ Enhanced Maintainability: Standardized architecture and shared components</a:t>
+              <a:t>🔒 Risk Mitigation: Enterprise security (Vault, rate limiting, audit trails) ensures compliance and reduces breach exposure</a:t>
             </a:r>
           </a:p>
           <a:p>
@@ -5670,7 +6677,7 @@
               </a:defRPr>
             </a:pPr>
             <a:r>
-              <a:t>✓ Enterprise Compliance: Built-in security, observability, and audit trails</a:t>
+              <a:t>🚀 Innovation Velocity: Engineers focus on differentiated business logic, not commodity infrastructure</a:t>
             </a:r>
           </a:p>
           <a:p>
@@ -5685,7 +6692,7 @@
               </a:defRPr>
             </a:pPr>
             <a:r>
-              <a:t>✓ Knowledge Retention: Self-documenting codebase with learning resources</a:t>
+              <a:t>📊 Organizational Capability: Standardization enables knowledge transfer—reduce dependency on individual experts</a:t>
             </a:r>
           </a:p>
         </p:txBody>
@@ -5698,8 +6705,8 @@
 </p:sld>
 </file>
 
-<file path=ppt/slides/slide15.xml><?xml version="1.0" encoding="utf-8"?>
-<p:sld xmlns:a="http://schemas.openxmlformats.org/drawingml/2006/main" xmlns:p="http://schemas.openxmlformats.org/presentationml/2006/main" xmlns:r="http://schemas.openxmlformats.org/officeDocument/2006/relationships">
+<file path=ppt/slides/slide17.xml><?xml version="1.0" encoding="utf-8"?>
+<p:sld xmlns:a="http://schemas.openxmlformats.org/drawingml/2006/main" xmlns:r="http://schemas.openxmlformats.org/officeDocument/2006/relationships" xmlns:p="http://schemas.openxmlformats.org/presentationml/2006/main">
   <p:cSld>
     <p:spTree>
       <p:nvGrpSpPr>
@@ -5707,7 +6714,14 @@
         <p:cNvGrpSpPr/>
         <p:nvPr/>
       </p:nvGrpSpPr>
-      <p:grpSpPr/>
+      <p:grpSpPr>
+        <a:xfrm>
+          <a:off x="0" y="0"/>
+          <a:ext cx="0" cy="0"/>
+          <a:chOff x="0" y="0"/>
+          <a:chExt cx="0" cy="0"/>
+        </a:xfrm>
+      </p:grpSpPr>
       <p:sp>
         <p:nvSpPr>
           <p:cNvPr id="2" name="Rectangle 1"/>
@@ -5748,6 +6762,7 @@
           <a:lstStyle/>
           <a:p>
             <a:pPr algn="ctr"/>
+            <a:endParaRPr/>
           </a:p>
         </p:txBody>
       </p:sp>
@@ -5781,7 +6796,7 @@
               </a:defRPr>
             </a:pPr>
             <a:r>
-              <a:t>Next Steps</a:t>
+              <a:t>Strategic Action Plan</a:t>
             </a:r>
           </a:p>
         </p:txBody>
@@ -5819,7 +6834,7 @@
               </a:defRPr>
             </a:pPr>
             <a:r>
-              <a:t>1. Pilot Project: Select a high-value use case for framework evaluation</a:t>
+              <a:t>1. Pilot Selection (Week 1): Identify high-impact use case aligned with strategic initiatives</a:t>
             </a:r>
           </a:p>
           <a:p>
@@ -5834,7 +6849,7 @@
               </a:defRPr>
             </a:pPr>
             <a:r>
-              <a:t>2. Team Training: 2-day workshop on LangChain, LangGraph, and framework SDK</a:t>
+              <a:t>2. Team Enablement (Week 2): Intensive 2-day workshop on framework, LangChain, and best practices</a:t>
             </a:r>
           </a:p>
           <a:p>
@@ -5849,7 +6864,7 @@
               </a:defRPr>
             </a:pPr>
             <a:r>
-              <a:t>3. Infrastructure Setup: Deploy Ollama server and Vault for team collaboration</a:t>
+              <a:t>3. Infrastructure Activation (Week 2): Deploy Ollama, Vault, and observability stack</a:t>
             </a:r>
           </a:p>
           <a:p>
@@ -5864,7 +6879,7 @@
               </a:defRPr>
             </a:pPr>
             <a:r>
-              <a:t>4. Development Sprint: Build 3-5 agents using the framework over 4 weeks</a:t>
+              <a:t>4. Rapid Prototyping (Weeks 3-6): Build 3-5 production agents with 87% faster velocity</a:t>
             </a:r>
           </a:p>
           <a:p>
@@ -5879,7 +6894,7 @@
               </a:defRPr>
             </a:pPr>
             <a:r>
-              <a:t>5. Production Rollout: Deploy first agent and measure business impact</a:t>
+              <a:t>5. Business Validation (Week 7): Measure ROI, capture lessons, scale successful patterns</a:t>
             </a:r>
           </a:p>
         </p:txBody>
@@ -5914,12 +6929,12 @@
               </a:defRPr>
             </a:pPr>
             <a:r>
-              <a:t>Ready to accelerate your AI development?</a:t>
-            </a:r>
-          </a:p>
-          <a:p>
-            <a:r>
-              <a:t>Let's discuss how this framework can transform your team's productivity.</a:t>
+              <a:t>The future of AI development isn't about working harder—it's about working smarter.</a:t>
+            </a:r>
+          </a:p>
+          <a:p>
+            <a:r>
+              <a:t>Let's accelerate your organization's AI transformation together.</a:t>
             </a:r>
           </a:p>
         </p:txBody>
@@ -5933,7 +6948,7 @@
 </file>
 
 <file path=ppt/slides/slide2.xml><?xml version="1.0" encoding="utf-8"?>
-<p:sld xmlns:a="http://schemas.openxmlformats.org/drawingml/2006/main" xmlns:p="http://schemas.openxmlformats.org/presentationml/2006/main" xmlns:r="http://schemas.openxmlformats.org/officeDocument/2006/relationships">
+<p:sld xmlns:a="http://schemas.openxmlformats.org/drawingml/2006/main" xmlns:r="http://schemas.openxmlformats.org/officeDocument/2006/relationships" xmlns:p="http://schemas.openxmlformats.org/presentationml/2006/main">
   <p:cSld>
     <p:spTree>
       <p:nvGrpSpPr>
@@ -5941,7 +6956,14 @@
         <p:cNvGrpSpPr/>
         <p:nvPr/>
       </p:nvGrpSpPr>
-      <p:grpSpPr/>
+      <p:grpSpPr>
+        <a:xfrm>
+          <a:off x="0" y="0"/>
+          <a:ext cx="0" cy="0"/>
+          <a:chOff x="0" y="0"/>
+          <a:chExt cx="0" cy="0"/>
+        </a:xfrm>
+      </p:grpSpPr>
       <p:sp>
         <p:nvSpPr>
           <p:cNvPr id="2" name="TextBox 1"/>
@@ -6017,6 +7039,7 @@
           <a:lstStyle/>
           <a:p>
             <a:pPr algn="ctr"/>
+            <a:endParaRPr/>
           </a:p>
         </p:txBody>
       </p:sp>
@@ -6041,7 +7064,9 @@
             <a:spAutoFit/>
           </a:bodyPr>
           <a:lstStyle/>
-          <a:p/>
+          <a:p>
+            <a:endParaRPr/>
+          </a:p>
           <a:p>
             <a:pPr>
               <a:spcBef>
@@ -6054,7 +7079,7 @@
               </a:defRPr>
             </a:pPr>
             <a:r>
-              <a:t>The Challenge</a:t>
+              <a:t>The Strategic Challenge</a:t>
             </a:r>
           </a:p>
           <a:p>
@@ -6069,7 +7094,7 @@
               </a:defRPr>
             </a:pPr>
             <a:r>
-              <a:t>Building production-ready AI agents requires significant infrastructure: LLM orchestration, vector stores, caching, observability, testing, and secret management. Development teams typically spend 15+ minutes per project on boilerplate setup.</a:t>
+              <a:t>Organizations investing in AI face a critical bottleneck: Every new AI initiative requires 15-20 minutes of infrastructure setup per project—multiplied across teams, this translates to thousands of wasted engineering hours annually. Complex dependencies on LLM orchestration, vector stores, observability, and security create barriers to rapid innovation.</a:t>
             </a:r>
           </a:p>
           <a:p>
@@ -6084,7 +7109,7 @@
               </a:defRPr>
             </a:pPr>
             <a:r>
-              <a:t>Our Solution</a:t>
+              <a:t>Our Transformative Solution</a:t>
             </a:r>
           </a:p>
           <a:p>
@@ -6099,7 +7124,7 @@
               </a:defRPr>
             </a:pPr>
             <a:r>
-              <a:t>A comprehensive Python monorepo with SDK tooling that reduces project scaffolding from 15 minutes to under 2 minutes while enforcing 90% test coverage and production-ready patterns.</a:t>
+              <a:t>An enterprise-grade AI development platform that eliminates infrastructure friction. Our SDK-powered framework reduces project inception from 15 minutes to under 2 minutes—an 87% efficiency gain—while automatically enforcing production-ready patterns, 90% test coverage, and enterprise security standards.</a:t>
             </a:r>
           </a:p>
           <a:p>
@@ -6114,7 +7139,7 @@
               </a:defRPr>
             </a:pPr>
             <a:r>
-              <a:t>Key Value Proposition</a:t>
+              <a:t>Compelling Value Proposition</a:t>
             </a:r>
           </a:p>
           <a:p>
@@ -6129,19 +7154,23 @@
               </a:defRPr>
             </a:pPr>
             <a:r>
-              <a:t>• Accelerated Time-to-Market: 87% faster project setup</a:t>
+              <a:t>💰 ROI Impact: 87% faster project setup = 10x more AI initiatives per quarter</a:t>
             </a:r>
             <a:br/>
             <a:r>
-              <a:t>• Enterprise-Grade: Built-in Vault integration, rate limiting, retry logic</a:t>
+              <a:t>🔒 Risk Mitigation: Built-in Vault integration, rate limiting, and audit trails ensure compliance</a:t>
             </a:r>
             <a:br/>
             <a:r>
-              <a:t>• Composable Architecture: Mix-and-match integrations (pgvector, Redis, Langfuse)</a:t>
+              <a:t>⚡ Competitive Advantage: Composable architecture enables rapid experimentation and deployment</a:t>
             </a:r>
             <a:br/>
             <a:r>
-              <a:t>• Quality Assurance: Automated test generation with 90% coverage enforcement</a:t>
+              <a:t>📊 Quality Guarantee: Automated testing with 90% coverage eliminates production surprises</a:t>
+            </a:r>
+            <a:br/>
+            <a:r>
+              <a:t>🎯 Strategic Enablement: Teams focus on business logic, not infrastructure plumbing</a:t>
             </a:r>
           </a:p>
         </p:txBody>
@@ -6155,7 +7184,7 @@
 </file>
 
 <file path=ppt/slides/slide3.xml><?xml version="1.0" encoding="utf-8"?>
-<p:sld xmlns:a="http://schemas.openxmlformats.org/drawingml/2006/main" xmlns:p="http://schemas.openxmlformats.org/presentationml/2006/main" xmlns:r="http://schemas.openxmlformats.org/officeDocument/2006/relationships">
+<p:sld xmlns:a="http://schemas.openxmlformats.org/drawingml/2006/main" xmlns:r="http://schemas.openxmlformats.org/officeDocument/2006/relationships" xmlns:p="http://schemas.openxmlformats.org/presentationml/2006/main">
   <p:cSld>
     <p:spTree>
       <p:nvGrpSpPr>
@@ -6163,7 +7192,14 @@
         <p:cNvGrpSpPr/>
         <p:nvPr/>
       </p:nvGrpSpPr>
-      <p:grpSpPr/>
+      <p:grpSpPr>
+        <a:xfrm>
+          <a:off x="0" y="0"/>
+          <a:ext cx="0" cy="0"/>
+          <a:chOff x="0" y="0"/>
+          <a:chExt cx="0" cy="0"/>
+        </a:xfrm>
+      </p:grpSpPr>
       <p:sp>
         <p:nvSpPr>
           <p:cNvPr id="2" name="TextBox 1"/>
@@ -6194,7 +7230,7 @@
               </a:defRPr>
             </a:pPr>
             <a:r>
-              <a:t>What is the Agentic AI Development Framework?</a:t>
+              <a:t>Who Benefits from This Framework?</a:t>
             </a:r>
           </a:p>
         </p:txBody>
@@ -6239,6 +7275,7 @@
           <a:lstStyle/>
           <a:p>
             <a:pPr algn="ctr"/>
+            <a:endParaRPr/>
           </a:p>
         </p:txBody>
       </p:sp>
@@ -6251,7 +7288,7 @@
         <p:spPr>
           <a:xfrm>
             <a:off x="731520" y="1645920"/>
-            <a:ext cx="7680960" cy="4389120"/>
+            <a:ext cx="7680960" cy="4572000"/>
           </a:xfrm>
           <a:prstGeom prst="rect">
             <a:avLst/>
@@ -6275,151 +7312,187 @@
               </a:defRPr>
             </a:pPr>
             <a:r>
-              <a:t>A Production-Ready Monorepo for Building Intelligent AI Agents</a:t>
+              <a:t>Strategic Alignment Across Your Organization</a:t>
             </a:r>
           </a:p>
           <a:p>
             <a:pPr>
-              <a:spcAft>
-                <a:spcPts val="600"/>
-              </a:spcAft>
-              <a:defRPr sz="1200">
-                <a:solidFill>
-                  <a:srgbClr val="323232"/>
-                </a:solidFill>
-              </a:defRPr>
-            </a:pPr>
-            <a:r>
-              <a:t>The framework is a curated collection of LangChain and LangGraph-based AI projects with shared utilities, automated scaffolding, and enterprise-grade integrations.</a:t>
+              <a:spcBef>
+                <a:spcPts val="0"/>
+              </a:spcBef>
+              <a:defRPr sz="1300" b="1">
+                <a:solidFill>
+                  <a:srgbClr val="0078D4"/>
+                </a:solidFill>
+              </a:defRPr>
+            </a:pPr>
+            <a:r>
+              <a:t>🎯 Executive Leadership</a:t>
+            </a:r>
+          </a:p>
+          <a:p>
+            <a:pPr lvl="1">
+              <a:spcAft>
+                <a:spcPts val="400"/>
+              </a:spcAft>
+              <a:defRPr sz="1000">
+                <a:solidFill>
+                  <a:srgbClr val="323232"/>
+                </a:solidFill>
+              </a:defRPr>
+            </a:pPr>
+            <a:r>
+              <a:t>Accelerate AI transformation initiatives with measurable ROI. Reduce time-to-market by 87% while maintaining enterprise-grade security and compliance standards.</a:t>
             </a:r>
           </a:p>
           <a:p>
             <a:pPr>
-              <a:spcAft>
-                <a:spcPts val="600"/>
-              </a:spcAft>
-              <a:defRPr sz="1200">
-                <a:solidFill>
-                  <a:srgbClr val="323232"/>
-                </a:solidFill>
-              </a:defRPr>
-            </a:pPr>
+              <a:spcBef>
+                <a:spcPts val="1000"/>
+              </a:spcBef>
+              <a:defRPr sz="1300" b="1">
+                <a:solidFill>
+                  <a:srgbClr val="0078D4"/>
+                </a:solidFill>
+              </a:defRPr>
+            </a:pPr>
+            <a:r>
+              <a:t>💼 Engineering Managers</a:t>
+            </a:r>
+          </a:p>
+          <a:p>
+            <a:pPr lvl="1">
+              <a:spcAft>
+                <a:spcPts val="400"/>
+              </a:spcAft>
+              <a:defRPr sz="1000">
+                <a:solidFill>
+                  <a:srgbClr val="323232"/>
+                </a:solidFill>
+              </a:defRPr>
+            </a:pPr>
+            <a:r>
+              <a:t>Empower your teams with production-ready infrastructure. Eliminate boilerplate setup, enforce quality standards, and scale AI development without expanding headcount.</a:t>
+            </a:r>
           </a:p>
           <a:p>
             <a:pPr>
-              <a:spcAft>
-                <a:spcPts val="600"/>
-              </a:spcAft>
-              <a:defRPr sz="1200">
-                <a:solidFill>
-                  <a:srgbClr val="323232"/>
-                </a:solidFill>
-              </a:defRPr>
-            </a:pPr>
-            <a:r>
-              <a:t>Unlike traditional AI development where teams start from scratch for each project, our framework provides:</a:t>
+              <a:spcBef>
+                <a:spcPts val="1000"/>
+              </a:spcBef>
+              <a:defRPr sz="1300" b="1">
+                <a:solidFill>
+                  <a:srgbClr val="0078D4"/>
+                </a:solidFill>
+              </a:defRPr>
+            </a:pPr>
+            <a:r>
+              <a:t>👨‍💻 Development Teams</a:t>
+            </a:r>
+          </a:p>
+          <a:p>
+            <a:pPr lvl="1">
+              <a:spcAft>
+                <a:spcPts val="400"/>
+              </a:spcAft>
+              <a:defRPr sz="1000">
+                <a:solidFill>
+                  <a:srgbClr val="323232"/>
+                </a:solidFill>
+              </a:defRPr>
+            </a:pPr>
+            <a:r>
+              <a:t>Focus on innovation, not infrastructure. Pre-built integrations, automated testing, and shared components free developers to solve business problems, not plumbing.</a:t>
             </a:r>
           </a:p>
           <a:p>
             <a:pPr>
-              <a:spcAft>
-                <a:spcPts val="600"/>
-              </a:spcAft>
-              <a:defRPr sz="1200">
-                <a:solidFill>
-                  <a:srgbClr val="323232"/>
-                </a:solidFill>
-              </a:defRPr>
-            </a:pPr>
+              <a:spcBef>
+                <a:spcPts val="1000"/>
+              </a:spcBef>
+              <a:defRPr sz="1300" b="1">
+                <a:solidFill>
+                  <a:srgbClr val="0078D4"/>
+                </a:solidFill>
+              </a:defRPr>
+            </a:pPr>
+            <a:r>
+              <a:t>🔬 Data Scientists &amp; AI Researchers</a:t>
+            </a:r>
+          </a:p>
+          <a:p>
+            <a:pPr lvl="1">
+              <a:spcAft>
+                <a:spcPts val="400"/>
+              </a:spcAft>
+              <a:defRPr sz="1000">
+                <a:solidFill>
+                  <a:srgbClr val="323232"/>
+                </a:solidFill>
+              </a:defRPr>
+            </a:pPr>
+            <a:r>
+              <a:t>Rapidly prototype and productionize AI models. Seamless path from experimentation to production deployment with built-in observability and performance tracking.</a:t>
+            </a:r>
           </a:p>
           <a:p>
             <a:pPr>
-              <a:spcAft>
-                <a:spcPts val="600"/>
-              </a:spcAft>
-              <a:defRPr sz="1200">
-                <a:solidFill>
-                  <a:srgbClr val="323232"/>
-                </a:solidFill>
-              </a:defRPr>
-            </a:pPr>
-            <a:r>
-              <a:t>✓ Standardized Architecture: Consistent project structure across all agents</a:t>
+              <a:spcBef>
+                <a:spcPts val="1000"/>
+              </a:spcBef>
+              <a:defRPr sz="1300" b="1">
+                <a:solidFill>
+                  <a:srgbClr val="0078D4"/>
+                </a:solidFill>
+              </a:defRPr>
+            </a:pPr>
+            <a:r>
+              <a:t>🏢 IT Operations &amp; DevOps</a:t>
+            </a:r>
+          </a:p>
+          <a:p>
+            <a:pPr lvl="1">
+              <a:spcAft>
+                <a:spcPts val="400"/>
+              </a:spcAft>
+              <a:defRPr sz="1000">
+                <a:solidFill>
+                  <a:srgbClr val="323232"/>
+                </a:solidFill>
+              </a:defRPr>
+            </a:pPr>
+            <a:r>
+              <a:t>Standardized architecture reduces operational complexity. Vault integration, rate limiting, and retry logic ensure reliability at scale.</a:t>
             </a:r>
           </a:p>
           <a:p>
             <a:pPr>
-              <a:spcAft>
-                <a:spcPts val="600"/>
-              </a:spcAft>
-              <a:defRPr sz="1200">
-                <a:solidFill>
-                  <a:srgbClr val="323232"/>
-                </a:solidFill>
-              </a:defRPr>
-            </a:pPr>
-            <a:r>
-              <a:t>✓ Shared Components: Reusable LLM factory, prompts, utilities, and error handling</a:t>
-            </a:r>
-          </a:p>
-          <a:p>
-            <a:pPr>
-              <a:spcAft>
-                <a:spcPts val="600"/>
-              </a:spcAft>
-              <a:defRPr sz="1200">
-                <a:solidFill>
-                  <a:srgbClr val="323232"/>
-                </a:solidFill>
-              </a:defRPr>
-            </a:pPr>
-            <a:r>
-              <a:t>✓ SDK-Powered Scaffolding: Auto-generate projects with one CLI command</a:t>
-            </a:r>
-          </a:p>
-          <a:p>
-            <a:pPr>
-              <a:spcAft>
-                <a:spcPts val="600"/>
-              </a:spcAft>
-              <a:defRPr sz="1200">
-                <a:solidFill>
-                  <a:srgbClr val="323232"/>
-                </a:solidFill>
-              </a:defRPr>
-            </a:pPr>
-            <a:r>
-              <a:t>✓ Built-in Best Practices: 90% test coverage, mocked LLMs, production patterns</a:t>
-            </a:r>
-          </a:p>
-          <a:p>
-            <a:pPr>
-              <a:spcAft>
-                <a:spcPts val="600"/>
-              </a:spcAft>
-              <a:defRPr sz="1200">
-                <a:solidFill>
-                  <a:srgbClr val="323232"/>
-                </a:solidFill>
-              </a:defRPr>
-            </a:pPr>
-            <a:r>
-              <a:t>✓ Enterprise Integration: HashiCorp Vault, rate limiting, token counting, retry logic</a:t>
-            </a:r>
-          </a:p>
-          <a:p>
-            <a:pPr>
-              <a:spcAft>
-                <a:spcPts val="600"/>
-              </a:spcAft>
-              <a:defRPr sz="1200">
-                <a:solidFill>
-                  <a:srgbClr val="323232"/>
-                </a:solidFill>
-              </a:defRPr>
-            </a:pPr>
-            <a:r>
-              <a:t>✓ Learning Resources: Quick-reference guides for Agentic AI, ReAct, RAG patterns</a:t>
+              <a:spcBef>
+                <a:spcPts val="1000"/>
+              </a:spcBef>
+              <a:defRPr sz="1300" b="1">
+                <a:solidFill>
+                  <a:srgbClr val="0078D4"/>
+                </a:solidFill>
+              </a:defRPr>
+            </a:pPr>
+            <a:r>
+              <a:t>📊 Product &amp; Business Stakeholders</a:t>
+            </a:r>
+          </a:p>
+          <a:p>
+            <a:pPr lvl="1">
+              <a:spcAft>
+                <a:spcPts val="400"/>
+              </a:spcAft>
+              <a:defRPr sz="1000">
+                <a:solidFill>
+                  <a:srgbClr val="323232"/>
+                </a:solidFill>
+              </a:defRPr>
+            </a:pPr>
+            <a:r>
+              <a:t>Faster iteration cycles mean quicker validation of AI use cases. Clear metrics and observability enable data-driven product decisions.</a:t>
             </a:r>
           </a:p>
         </p:txBody>
@@ -6433,7 +7506,7 @@
 </file>
 
 <file path=ppt/slides/slide4.xml><?xml version="1.0" encoding="utf-8"?>
-<p:sld xmlns:a="http://schemas.openxmlformats.org/drawingml/2006/main" xmlns:p="http://schemas.openxmlformats.org/presentationml/2006/main" xmlns:r="http://schemas.openxmlformats.org/officeDocument/2006/relationships">
+<p:sld xmlns:a="http://schemas.openxmlformats.org/drawingml/2006/main" xmlns:r="http://schemas.openxmlformats.org/officeDocument/2006/relationships" xmlns:p="http://schemas.openxmlformats.org/presentationml/2006/main">
   <p:cSld>
     <p:spTree>
       <p:nvGrpSpPr>
@@ -6441,7 +7514,14 @@
         <p:cNvGrpSpPr/>
         <p:nvPr/>
       </p:nvGrpSpPr>
-      <p:grpSpPr/>
+      <p:grpSpPr>
+        <a:xfrm>
+          <a:off x="0" y="0"/>
+          <a:ext cx="0" cy="0"/>
+          <a:chOff x="0" y="0"/>
+          <a:chExt cx="0" cy="0"/>
+        </a:xfrm>
+      </p:grpSpPr>
       <p:sp>
         <p:nvSpPr>
           <p:cNvPr id="2" name="TextBox 1"/>
@@ -6472,7 +7552,7 @@
               </a:defRPr>
             </a:pPr>
             <a:r>
-              <a:t>Technology Stack</a:t>
+              <a:t>Comprehensive Scope &amp; Strategic Features</a:t>
             </a:r>
           </a:p>
         </p:txBody>
@@ -6517,6 +7597,677 @@
           <a:lstStyle/>
           <a:p>
             <a:pPr algn="ctr"/>
+            <a:endParaRPr/>
+          </a:p>
+        </p:txBody>
+      </p:sp>
+      <p:sp>
+        <p:nvSpPr>
+          <p:cNvPr id="4" name="TextBox 3"/>
+          <p:cNvSpPr txBox="1"/>
+          <p:nvPr/>
+        </p:nvSpPr>
+        <p:spPr>
+          <a:xfrm>
+            <a:off x="731520" y="1645920"/>
+            <a:ext cx="7680960" cy="4572000"/>
+          </a:xfrm>
+          <a:prstGeom prst="rect">
+            <a:avLst/>
+          </a:prstGeom>
+          <a:noFill/>
+        </p:spPr>
+        <p:txBody>
+          <a:bodyPr wrap="square">
+            <a:spAutoFit/>
+          </a:bodyPr>
+          <a:lstStyle/>
+          <a:p>
+            <a:pPr>
+              <a:spcAft>
+                <a:spcPts val="1600"/>
+              </a:spcAft>
+              <a:defRPr sz="1800" b="1">
+                <a:solidFill>
+                  <a:srgbClr val="107C10"/>
+                </a:solidFill>
+              </a:defRPr>
+            </a:pPr>
+            <a:r>
+              <a:t>End-to-End AI Agent Development Platform</a:t>
+            </a:r>
+          </a:p>
+          <a:p>
+            <a:pPr>
+              <a:spcBef>
+                <a:spcPts val="0"/>
+              </a:spcBef>
+              <a:defRPr sz="1300" b="1">
+                <a:solidFill>
+                  <a:srgbClr val="0078D4"/>
+                </a:solidFill>
+              </a:defRPr>
+            </a:pPr>
+            <a:r>
+              <a:t>🚀 Rapid Development &amp; Deployment</a:t>
+            </a:r>
+          </a:p>
+          <a:p>
+            <a:pPr lvl="1">
+              <a:spcAft>
+                <a:spcPts val="200"/>
+              </a:spcAft>
+              <a:defRPr sz="1000">
+                <a:solidFill>
+                  <a:srgbClr val="323232"/>
+                </a:solidFill>
+              </a:defRPr>
+            </a:pPr>
+            <a:r>
+              <a:t>• 87% faster project setup (15 min → 2 min) with AI Agent Builder SDK</a:t>
+            </a:r>
+          </a:p>
+          <a:p>
+            <a:pPr lvl="1">
+              <a:spcAft>
+                <a:spcPts val="200"/>
+              </a:spcAft>
+              <a:defRPr sz="1000">
+                <a:solidFill>
+                  <a:srgbClr val="323232"/>
+                </a:solidFill>
+              </a:defRPr>
+            </a:pPr>
+            <a:r>
+              <a:t>• One-command scaffolding generates complete, production-ready project structure</a:t>
+            </a:r>
+          </a:p>
+          <a:p>
+            <a:pPr lvl="1">
+              <a:spcAft>
+                <a:spcPts val="200"/>
+              </a:spcAft>
+              <a:defRPr sz="1000">
+                <a:solidFill>
+                  <a:srgbClr val="323232"/>
+                </a:solidFill>
+              </a:defRPr>
+            </a:pPr>
+            <a:r>
+              <a:t>• Pre-configured CI/CD templates and deployment pipelines</a:t>
+            </a:r>
+          </a:p>
+          <a:p>
+            <a:pPr>
+              <a:spcBef>
+                <a:spcPts val="1000"/>
+              </a:spcBef>
+              <a:defRPr sz="1300" b="1">
+                <a:solidFill>
+                  <a:srgbClr val="0078D4"/>
+                </a:solidFill>
+              </a:defRPr>
+            </a:pPr>
+            <a:r>
+              <a:t>🏗️ Enterprise-Grade Architecture</a:t>
+            </a:r>
+          </a:p>
+          <a:p>
+            <a:pPr lvl="1">
+              <a:spcAft>
+                <a:spcPts val="200"/>
+              </a:spcAft>
+              <a:defRPr sz="1000">
+                <a:solidFill>
+                  <a:srgbClr val="323232"/>
+                </a:solidFill>
+              </a:defRPr>
+            </a:pPr>
+            <a:r>
+              <a:t>• Shared component library: LLM factory, authentication, error handling, caching</a:t>
+            </a:r>
+          </a:p>
+          <a:p>
+            <a:pPr lvl="1">
+              <a:spcAft>
+                <a:spcPts val="200"/>
+              </a:spcAft>
+              <a:defRPr sz="1000">
+                <a:solidFill>
+                  <a:srgbClr val="323232"/>
+                </a:solidFill>
+              </a:defRPr>
+            </a:pPr>
+            <a:r>
+              <a:t>• Composable integrations: Vector stores (pgvector, Chroma, FAISS), Redis caching, Langfuse observability</a:t>
+            </a:r>
+          </a:p>
+          <a:p>
+            <a:pPr lvl="1">
+              <a:spcAft>
+                <a:spcPts val="200"/>
+              </a:spcAft>
+              <a:defRPr sz="1000">
+                <a:solidFill>
+                  <a:srgbClr val="323232"/>
+                </a:solidFill>
+              </a:defRPr>
+            </a:pPr>
+            <a:r>
+              <a:t>• Hierarchical environment management with HashiCorp Vault for secrets</a:t>
+            </a:r>
+          </a:p>
+          <a:p>
+            <a:pPr>
+              <a:spcBef>
+                <a:spcPts val="1000"/>
+              </a:spcBef>
+              <a:defRPr sz="1300" b="1">
+                <a:solidFill>
+                  <a:srgbClr val="0078D4"/>
+                </a:solidFill>
+              </a:defRPr>
+            </a:pPr>
+            <a:r>
+              <a:t>🛡️ Production-Ready Infrastructure</a:t>
+            </a:r>
+          </a:p>
+          <a:p>
+            <a:pPr lvl="1">
+              <a:spcAft>
+                <a:spcPts val="200"/>
+              </a:spcAft>
+              <a:defRPr sz="1000">
+                <a:solidFill>
+                  <a:srgbClr val="323232"/>
+                </a:solidFill>
+              </a:defRPr>
+            </a:pPr>
+            <a:r>
+              <a:t>• Built-in rate limiting (token bucket) and exponential backoff retry logic</a:t>
+            </a:r>
+          </a:p>
+          <a:p>
+            <a:pPr lvl="1">
+              <a:spcAft>
+                <a:spcPts val="200"/>
+              </a:spcAft>
+              <a:defRPr sz="1000">
+                <a:solidFill>
+                  <a:srgbClr val="323232"/>
+                </a:solidFill>
+              </a:defRPr>
+            </a:pPr>
+            <a:r>
+              <a:t>• Comprehensive observability: Token counting, cost tracking, distributed tracing</a:t>
+            </a:r>
+          </a:p>
+          <a:p>
+            <a:pPr lvl="1">
+              <a:spcAft>
+                <a:spcPts val="200"/>
+              </a:spcAft>
+              <a:defRPr sz="1000">
+                <a:solidFill>
+                  <a:srgbClr val="323232"/>
+                </a:solidFill>
+              </a:defRPr>
+            </a:pPr>
+            <a:r>
+              <a:t>• 90% test coverage enforcement with automated test generation</a:t>
+            </a:r>
+          </a:p>
+          <a:p>
+            <a:pPr>
+              <a:spcBef>
+                <a:spcPts val="1000"/>
+              </a:spcBef>
+              <a:defRPr sz="1300" b="1">
+                <a:solidFill>
+                  <a:srgbClr val="0078D4"/>
+                </a:solidFill>
+              </a:defRPr>
+            </a:pPr>
+            <a:r>
+              <a:t>📈 Business Enablement</a:t>
+            </a:r>
+          </a:p>
+          <a:p>
+            <a:pPr lvl="1">
+              <a:spcAft>
+                <a:spcPts val="200"/>
+              </a:spcAft>
+              <a:defRPr sz="1000">
+                <a:solidFill>
+                  <a:srgbClr val="323232"/>
+                </a:solidFill>
+              </a:defRPr>
+            </a:pPr>
+            <a:r>
+              <a:t>• 5-level automation maturity model: From manual operations to autonomous AI agents</a:t>
+            </a:r>
+          </a:p>
+          <a:p>
+            <a:pPr lvl="1">
+              <a:spcAft>
+                <a:spcPts val="200"/>
+              </a:spcAft>
+              <a:defRPr sz="1000">
+                <a:solidFill>
+                  <a:srgbClr val="323232"/>
+                </a:solidFill>
+              </a:defRPr>
+            </a:pPr>
+            <a:r>
+              <a:t>• Real-world use cases: GitHub integration, weather reporting, automation orchestration</a:t>
+            </a:r>
+          </a:p>
+          <a:p>
+            <a:pPr lvl="1">
+              <a:spcAft>
+                <a:spcPts val="200"/>
+              </a:spcAft>
+              <a:defRPr sz="1000">
+                <a:solidFill>
+                  <a:srgbClr val="323232"/>
+                </a:solidFill>
+              </a:defRPr>
+            </a:pPr>
+            <a:r>
+              <a:t>• Extensible plugin architecture for custom integrations and business logic</a:t>
+            </a:r>
+          </a:p>
+        </p:txBody>
+      </p:sp>
+    </p:spTree>
+  </p:cSld>
+  <p:clrMapOvr>
+    <a:masterClrMapping/>
+  </p:clrMapOvr>
+</p:sld>
+</file>
+
+<file path=ppt/slides/slide5.xml><?xml version="1.0" encoding="utf-8"?>
+<p:sld xmlns:a="http://schemas.openxmlformats.org/drawingml/2006/main" xmlns:r="http://schemas.openxmlformats.org/officeDocument/2006/relationships" xmlns:p="http://schemas.openxmlformats.org/presentationml/2006/main">
+  <p:cSld>
+    <p:spTree>
+      <p:nvGrpSpPr>
+        <p:cNvPr id="1" name=""/>
+        <p:cNvGrpSpPr/>
+        <p:nvPr/>
+      </p:nvGrpSpPr>
+      <p:grpSpPr>
+        <a:xfrm>
+          <a:off x="0" y="0"/>
+          <a:ext cx="0" cy="0"/>
+          <a:chOff x="0" y="0"/>
+          <a:chExt cx="0" cy="0"/>
+        </a:xfrm>
+      </p:grpSpPr>
+      <p:sp>
+        <p:nvSpPr>
+          <p:cNvPr id="2" name="TextBox 1"/>
+          <p:cNvSpPr txBox="1"/>
+          <p:nvPr/>
+        </p:nvSpPr>
+        <p:spPr>
+          <a:xfrm>
+            <a:off x="457200" y="365760"/>
+            <a:ext cx="8229600" cy="731520"/>
+          </a:xfrm>
+          <a:prstGeom prst="rect">
+            <a:avLst/>
+          </a:prstGeom>
+          <a:noFill/>
+        </p:spPr>
+        <p:txBody>
+          <a:bodyPr wrap="none">
+            <a:spAutoFit/>
+          </a:bodyPr>
+          <a:lstStyle/>
+          <a:p>
+            <a:pPr>
+              <a:defRPr sz="2800" b="1">
+                <a:solidFill>
+                  <a:srgbClr val="0078D4"/>
+                </a:solidFill>
+              </a:defRPr>
+            </a:pPr>
+            <a:r>
+              <a:t>What is the Agentic AI Development Framework?</a:t>
+            </a:r>
+          </a:p>
+        </p:txBody>
+      </p:sp>
+      <p:sp>
+        <p:nvSpPr>
+          <p:cNvPr id="3" name="Rectangle 2"/>
+          <p:cNvSpPr/>
+          <p:nvPr/>
+        </p:nvSpPr>
+        <p:spPr>
+          <a:xfrm>
+            <a:off x="457200" y="1188720"/>
+            <a:ext cx="8229600" cy="18288"/>
+          </a:xfrm>
+          <a:prstGeom prst="rect">
+            <a:avLst/>
+          </a:prstGeom>
+          <a:solidFill>
+            <a:srgbClr val="0078D4"/>
+          </a:solidFill>
+          <a:ln>
+            <a:noFill/>
+          </a:ln>
+        </p:spPr>
+        <p:style>
+          <a:lnRef idx="1">
+            <a:schemeClr val="accent1"/>
+          </a:lnRef>
+          <a:fillRef idx="3">
+            <a:schemeClr val="accent1"/>
+          </a:fillRef>
+          <a:effectRef idx="2">
+            <a:schemeClr val="accent1"/>
+          </a:effectRef>
+          <a:fontRef idx="minor">
+            <a:schemeClr val="lt1"/>
+          </a:fontRef>
+        </p:style>
+        <p:txBody>
+          <a:bodyPr rtlCol="0" anchor="ctr"/>
+          <a:lstStyle/>
+          <a:p>
+            <a:pPr algn="ctr"/>
+            <a:endParaRPr/>
+          </a:p>
+        </p:txBody>
+      </p:sp>
+      <p:sp>
+        <p:nvSpPr>
+          <p:cNvPr id="4" name="TextBox 3"/>
+          <p:cNvSpPr txBox="1"/>
+          <p:nvPr/>
+        </p:nvSpPr>
+        <p:spPr>
+          <a:xfrm>
+            <a:off x="731520" y="1645920"/>
+            <a:ext cx="7680960" cy="4389120"/>
+          </a:xfrm>
+          <a:prstGeom prst="rect">
+            <a:avLst/>
+          </a:prstGeom>
+          <a:noFill/>
+        </p:spPr>
+        <p:txBody>
+          <a:bodyPr wrap="square">
+            <a:spAutoFit/>
+          </a:bodyPr>
+          <a:lstStyle/>
+          <a:p>
+            <a:pPr>
+              <a:spcAft>
+                <a:spcPts val="1600"/>
+              </a:spcAft>
+              <a:defRPr sz="1800" b="1">
+                <a:solidFill>
+                  <a:srgbClr val="107C10"/>
+                </a:solidFill>
+              </a:defRPr>
+            </a:pPr>
+            <a:r>
+              <a:t>The Future of Enterprise AI Development—Available Today</a:t>
+            </a:r>
+          </a:p>
+          <a:p>
+            <a:pPr>
+              <a:spcAft>
+                <a:spcPts val="600"/>
+              </a:spcAft>
+              <a:defRPr sz="1200">
+                <a:solidFill>
+                  <a:srgbClr val="323232"/>
+                </a:solidFill>
+              </a:defRPr>
+            </a:pPr>
+            <a:r>
+              <a:t>Transform how your organization builds and deploys AI agents. This isn't just a framework—it's a complete platform that eliminates the complexity barrier between AI innovation and production reality.</a:t>
+            </a:r>
+          </a:p>
+          <a:p>
+            <a:pPr>
+              <a:spcAft>
+                <a:spcPts val="600"/>
+              </a:spcAft>
+              <a:defRPr sz="1200">
+                <a:solidFill>
+                  <a:srgbClr val="323232"/>
+                </a:solidFill>
+              </a:defRPr>
+            </a:pPr>
+            <a:endParaRPr/>
+          </a:p>
+          <a:p>
+            <a:pPr>
+              <a:spcAft>
+                <a:spcPts val="600"/>
+              </a:spcAft>
+              <a:defRPr sz="1200">
+                <a:solidFill>
+                  <a:srgbClr val="323232"/>
+                </a:solidFill>
+              </a:defRPr>
+            </a:pPr>
+            <a:r>
+              <a:t>Built on battle-tested technologies (LangChain, LangGraph, Ollama), our platform provides:</a:t>
+            </a:r>
+          </a:p>
+          <a:p>
+            <a:pPr>
+              <a:spcAft>
+                <a:spcPts val="600"/>
+              </a:spcAft>
+              <a:defRPr sz="1200">
+                <a:solidFill>
+                  <a:srgbClr val="323232"/>
+                </a:solidFill>
+              </a:defRPr>
+            </a:pPr>
+            <a:endParaRPr/>
+          </a:p>
+          <a:p>
+            <a:pPr>
+              <a:spcAft>
+                <a:spcPts val="600"/>
+              </a:spcAft>
+              <a:defRPr sz="1200">
+                <a:solidFill>
+                  <a:srgbClr val="323232"/>
+                </a:solidFill>
+              </a:defRPr>
+            </a:pPr>
+            <a:r>
+              <a:t>✅ Zero-Configuration Architecture: Standardized structure means engineers onboard in hours, not weeks</a:t>
+            </a:r>
+          </a:p>
+          <a:p>
+            <a:pPr>
+              <a:spcAft>
+                <a:spcPts val="600"/>
+              </a:spcAft>
+              <a:defRPr sz="1200">
+                <a:solidFill>
+                  <a:srgbClr val="323232"/>
+                </a:solidFill>
+              </a:defRPr>
+            </a:pPr>
+            <a:r>
+              <a:t>✅ Enterprise-Grade Components: Reusable LLM factory, authentication, error handling—already production-hardened</a:t>
+            </a:r>
+          </a:p>
+          <a:p>
+            <a:pPr>
+              <a:spcAft>
+                <a:spcPts val="600"/>
+              </a:spcAft>
+              <a:defRPr sz="1200">
+                <a:solidFill>
+                  <a:srgbClr val="323232"/>
+                </a:solidFill>
+              </a:defRPr>
+            </a:pPr>
+            <a:r>
+              <a:t>✅ One-Command Intelligence: SDK generates complete projects in under 2 minutes, not hours</a:t>
+            </a:r>
+          </a:p>
+          <a:p>
+            <a:pPr>
+              <a:spcAft>
+                <a:spcPts val="600"/>
+              </a:spcAft>
+              <a:defRPr sz="1200">
+                <a:solidFill>
+                  <a:srgbClr val="323232"/>
+                </a:solidFill>
+              </a:defRPr>
+            </a:pPr>
+            <a:r>
+              <a:t>✅ Quality Baked In: 90% test coverage isn't optional—it's automated</a:t>
+            </a:r>
+          </a:p>
+          <a:p>
+            <a:pPr>
+              <a:spcAft>
+                <a:spcPts val="600"/>
+              </a:spcAft>
+              <a:defRPr sz="1200">
+                <a:solidFill>
+                  <a:srgbClr val="323232"/>
+                </a:solidFill>
+              </a:defRPr>
+            </a:pPr>
+            <a:r>
+              <a:t>✅ Security by Default: HashiCorp Vault, rate limiting, audit trails come standard</a:t>
+            </a:r>
+          </a:p>
+          <a:p>
+            <a:pPr>
+              <a:spcAft>
+                <a:spcPts val="600"/>
+              </a:spcAft>
+              <a:defRPr sz="1200">
+                <a:solidFill>
+                  <a:srgbClr val="323232"/>
+                </a:solidFill>
+              </a:defRPr>
+            </a:pPr>
+            <a:r>
+              <a:t>✅ Knowledge Transfer Built-In: Comprehensive guides for Agentic AI, ReAct, and RAG patterns accelerate team velocity</a:t>
+            </a:r>
+          </a:p>
+        </p:txBody>
+      </p:sp>
+    </p:spTree>
+  </p:cSld>
+  <p:clrMapOvr>
+    <a:masterClrMapping/>
+  </p:clrMapOvr>
+</p:sld>
+</file>
+
+<file path=ppt/slides/slide6.xml><?xml version="1.0" encoding="utf-8"?>
+<p:sld xmlns:a="http://schemas.openxmlformats.org/drawingml/2006/main" xmlns:r="http://schemas.openxmlformats.org/officeDocument/2006/relationships" xmlns:p="http://schemas.openxmlformats.org/presentationml/2006/main">
+  <p:cSld>
+    <p:spTree>
+      <p:nvGrpSpPr>
+        <p:cNvPr id="1" name=""/>
+        <p:cNvGrpSpPr/>
+        <p:nvPr/>
+      </p:nvGrpSpPr>
+      <p:grpSpPr>
+        <a:xfrm>
+          <a:off x="0" y="0"/>
+          <a:ext cx="0" cy="0"/>
+          <a:chOff x="0" y="0"/>
+          <a:chExt cx="0" cy="0"/>
+        </a:xfrm>
+      </p:grpSpPr>
+      <p:sp>
+        <p:nvSpPr>
+          <p:cNvPr id="2" name="TextBox 1"/>
+          <p:cNvSpPr txBox="1"/>
+          <p:nvPr/>
+        </p:nvSpPr>
+        <p:spPr>
+          <a:xfrm>
+            <a:off x="457200" y="365760"/>
+            <a:ext cx="8229600" cy="731520"/>
+          </a:xfrm>
+          <a:prstGeom prst="rect">
+            <a:avLst/>
+          </a:prstGeom>
+          <a:noFill/>
+        </p:spPr>
+        <p:txBody>
+          <a:bodyPr wrap="none">
+            <a:spAutoFit/>
+          </a:bodyPr>
+          <a:lstStyle/>
+          <a:p>
+            <a:pPr>
+              <a:defRPr sz="2800" b="1">
+                <a:solidFill>
+                  <a:srgbClr val="0078D4"/>
+                </a:solidFill>
+              </a:defRPr>
+            </a:pPr>
+            <a:r>
+              <a:t>Technology Stack</a:t>
+            </a:r>
+          </a:p>
+        </p:txBody>
+      </p:sp>
+      <p:sp>
+        <p:nvSpPr>
+          <p:cNvPr id="3" name="Rectangle 2"/>
+          <p:cNvSpPr/>
+          <p:nvPr/>
+        </p:nvSpPr>
+        <p:spPr>
+          <a:xfrm>
+            <a:off x="457200" y="1188720"/>
+            <a:ext cx="8229600" cy="18288"/>
+          </a:xfrm>
+          <a:prstGeom prst="rect">
+            <a:avLst/>
+          </a:prstGeom>
+          <a:solidFill>
+            <a:srgbClr val="0078D4"/>
+          </a:solidFill>
+          <a:ln>
+            <a:noFill/>
+          </a:ln>
+        </p:spPr>
+        <p:style>
+          <a:lnRef idx="1">
+            <a:schemeClr val="accent1"/>
+          </a:lnRef>
+          <a:fillRef idx="3">
+            <a:schemeClr val="accent1"/>
+          </a:fillRef>
+          <a:effectRef idx="2">
+            <a:schemeClr val="accent1"/>
+          </a:effectRef>
+          <a:fontRef idx="minor">
+            <a:schemeClr val="lt1"/>
+          </a:fontRef>
+        </p:style>
+        <p:txBody>
+          <a:bodyPr rtlCol="0" anchor="ctr"/>
+          <a:lstStyle/>
+          <a:p>
+            <a:pPr algn="ctr"/>
+            <a:endParaRPr/>
           </a:p>
         </p:txBody>
       </p:sp>
@@ -6539,8 +8290,20 @@
                 <a:tableStyleId>{5C22544A-7EE6-4342-B048-85BDC9FD1C3A}</a:tableStyleId>
               </a:tblPr>
               <a:tblGrid>
-                <a:gridCol w="2286000"/>
-                <a:gridCol w="4114800"/>
+                <a:gridCol w="2286000">
+                  <a:extLst>
+                    <a:ext uri="{9D8B030D-6E8A-4147-A177-3AD203B41FA5}">
+                      <a16:colId xmlns:a16="http://schemas.microsoft.com/office/drawing/2014/main" val="20000"/>
+                    </a:ext>
+                  </a:extLst>
+                </a:gridCol>
+                <a:gridCol w="4114800">
+                  <a:extLst>
+                    <a:ext uri="{9D8B030D-6E8A-4147-A177-3AD203B41FA5}">
+                      <a16:colId xmlns:a16="http://schemas.microsoft.com/office/drawing/2014/main" val="20001"/>
+                    </a:ext>
+                  </a:extLst>
+                </a:gridCol>
               </a:tblGrid>
               <a:tr h="457200">
                 <a:tc>
@@ -6549,7 +8312,7 @@
                     <a:lstStyle/>
                     <a:p>
                       <a:pPr>
-                        <a:defRPr b="1" sz="1200">
+                        <a:defRPr sz="1200" b="1">
                           <a:solidFill>
                             <a:srgbClr val="FFFFFF"/>
                           </a:solidFill>
@@ -6572,7 +8335,7 @@
                     <a:lstStyle/>
                     <a:p>
                       <a:pPr>
-                        <a:defRPr b="1" sz="1200">
+                        <a:defRPr sz="1200" b="1">
                           <a:solidFill>
                             <a:srgbClr val="FFFFFF"/>
                           </a:solidFill>
@@ -6589,6 +8352,11 @@
                     </a:solidFill>
                   </a:tcPr>
                 </a:tc>
+                <a:extLst>
+                  <a:ext uri="{0D108BD9-81ED-4DB2-BD59-A6C34878D82A}">
+                    <a16:rowId xmlns:a16="http://schemas.microsoft.com/office/drawing/2014/main" val="10000"/>
+                  </a:ext>
+                </a:extLst>
               </a:tr>
               <a:tr h="457200">
                 <a:tc>
@@ -6621,6 +8389,11 @@
                   </a:txBody>
                   <a:tcPr/>
                 </a:tc>
+                <a:extLst>
+                  <a:ext uri="{0D108BD9-81ED-4DB2-BD59-A6C34878D82A}">
+                    <a16:rowId xmlns:a16="http://schemas.microsoft.com/office/drawing/2014/main" val="10001"/>
+                  </a:ext>
+                </a:extLst>
               </a:tr>
               <a:tr h="457200">
                 <a:tc>
@@ -6661,6 +8434,11 @@
                     </a:solidFill>
                   </a:tcPr>
                 </a:tc>
+                <a:extLst>
+                  <a:ext uri="{0D108BD9-81ED-4DB2-BD59-A6C34878D82A}">
+                    <a16:rowId xmlns:a16="http://schemas.microsoft.com/office/drawing/2014/main" val="10002"/>
+                  </a:ext>
+                </a:extLst>
               </a:tr>
               <a:tr h="457200">
                 <a:tc>
@@ -6693,6 +8471,11 @@
                   </a:txBody>
                   <a:tcPr/>
                 </a:tc>
+                <a:extLst>
+                  <a:ext uri="{0D108BD9-81ED-4DB2-BD59-A6C34878D82A}">
+                    <a16:rowId xmlns:a16="http://schemas.microsoft.com/office/drawing/2014/main" val="10003"/>
+                  </a:ext>
+                </a:extLst>
               </a:tr>
               <a:tr h="457200">
                 <a:tc>
@@ -6733,6 +8516,11 @@
                     </a:solidFill>
                   </a:tcPr>
                 </a:tc>
+                <a:extLst>
+                  <a:ext uri="{0D108BD9-81ED-4DB2-BD59-A6C34878D82A}">
+                    <a16:rowId xmlns:a16="http://schemas.microsoft.com/office/drawing/2014/main" val="10004"/>
+                  </a:ext>
+                </a:extLst>
               </a:tr>
               <a:tr h="457200">
                 <a:tc>
@@ -6765,6 +8553,11 @@
                   </a:txBody>
                   <a:tcPr/>
                 </a:tc>
+                <a:extLst>
+                  <a:ext uri="{0D108BD9-81ED-4DB2-BD59-A6C34878D82A}">
+                    <a16:rowId xmlns:a16="http://schemas.microsoft.com/office/drawing/2014/main" val="10005"/>
+                  </a:ext>
+                </a:extLst>
               </a:tr>
               <a:tr h="457200">
                 <a:tc>
@@ -6805,6 +8598,11 @@
                     </a:solidFill>
                   </a:tcPr>
                 </a:tc>
+                <a:extLst>
+                  <a:ext uri="{0D108BD9-81ED-4DB2-BD59-A6C34878D82A}">
+                    <a16:rowId xmlns:a16="http://schemas.microsoft.com/office/drawing/2014/main" val="10006"/>
+                  </a:ext>
+                </a:extLst>
               </a:tr>
               <a:tr h="457200">
                 <a:tc>
@@ -6837,6 +8635,11 @@
                   </a:txBody>
                   <a:tcPr/>
                 </a:tc>
+                <a:extLst>
+                  <a:ext uri="{0D108BD9-81ED-4DB2-BD59-A6C34878D82A}">
+                    <a16:rowId xmlns:a16="http://schemas.microsoft.com/office/drawing/2014/main" val="10007"/>
+                  </a:ext>
+                </a:extLst>
               </a:tr>
             </a:tbl>
           </a:graphicData>
@@ -6850,8 +8653,8 @@
 </p:sld>
 </file>
 
-<file path=ppt/slides/slide5.xml><?xml version="1.0" encoding="utf-8"?>
-<p:sld xmlns:a="http://schemas.openxmlformats.org/drawingml/2006/main" xmlns:p="http://schemas.openxmlformats.org/presentationml/2006/main" xmlns:r="http://schemas.openxmlformats.org/officeDocument/2006/relationships">
+<file path=ppt/slides/slide7.xml><?xml version="1.0" encoding="utf-8"?>
+<p:sld xmlns:a="http://schemas.openxmlformats.org/drawingml/2006/main" xmlns:r="http://schemas.openxmlformats.org/officeDocument/2006/relationships" xmlns:p="http://schemas.openxmlformats.org/presentationml/2006/main">
   <p:cSld>
     <p:spTree>
       <p:nvGrpSpPr>
@@ -6859,7 +8662,14 @@
         <p:cNvGrpSpPr/>
         <p:nvPr/>
       </p:nvGrpSpPr>
-      <p:grpSpPr/>
+      <p:grpSpPr>
+        <a:xfrm>
+          <a:off x="0" y="0"/>
+          <a:ext cx="0" cy="0"/>
+          <a:chOff x="0" y="0"/>
+          <a:chExt cx="0" cy="0"/>
+        </a:xfrm>
+      </p:grpSpPr>
       <p:sp>
         <p:nvSpPr>
           <p:cNvPr id="2" name="TextBox 1"/>
@@ -6935,6 +8745,7 @@
           <a:lstStyle/>
           <a:p>
             <a:pPr algn="ctr"/>
+            <a:endParaRPr/>
           </a:p>
         </p:txBody>
       </p:sp>
@@ -6976,7 +8787,7 @@
           </a:fontRef>
         </p:style>
         <p:txBody>
-          <a:bodyPr rtlCol="0" anchor="ctr" wrap="square" tIns="91440" lIns="137160" rIns="137160"/>
+          <a:bodyPr wrap="square" lIns="137160" tIns="91440" rIns="137160" rtlCol="0" anchor="ctr"/>
           <a:lstStyle/>
           <a:p>
             <a:pPr algn="ctr">
@@ -7045,7 +8856,7 @@
           </a:fontRef>
         </p:style>
         <p:txBody>
-          <a:bodyPr rtlCol="0" anchor="ctr" wrap="square" tIns="91440" lIns="137160" rIns="137160"/>
+          <a:bodyPr wrap="square" lIns="137160" tIns="91440" rIns="137160" rtlCol="0" anchor="ctr"/>
           <a:lstStyle/>
           <a:p>
             <a:pPr algn="ctr">
@@ -7114,7 +8925,7 @@
           </a:fontRef>
         </p:style>
         <p:txBody>
-          <a:bodyPr rtlCol="0" anchor="ctr" wrap="square" tIns="91440" lIns="137160" rIns="137160"/>
+          <a:bodyPr wrap="square" lIns="137160" tIns="91440" rIns="137160" rtlCol="0" anchor="ctr"/>
           <a:lstStyle/>
           <a:p>
             <a:pPr algn="ctr">
@@ -7183,7 +8994,7 @@
           </a:fontRef>
         </p:style>
         <p:txBody>
-          <a:bodyPr rtlCol="0" anchor="ctr" wrap="square" tIns="91440" lIns="137160" rIns="137160"/>
+          <a:bodyPr wrap="square" lIns="137160" tIns="91440" rIns="137160" rtlCol="0" anchor="ctr"/>
           <a:lstStyle/>
           <a:p>
             <a:pPr algn="ctr">
@@ -7252,7 +9063,7 @@
           </a:fontRef>
         </p:style>
         <p:txBody>
-          <a:bodyPr rtlCol="0" anchor="ctr" wrap="square" tIns="91440" lIns="137160" rIns="137160"/>
+          <a:bodyPr wrap="square" lIns="137160" tIns="91440" rIns="137160" rtlCol="0" anchor="ctr"/>
           <a:lstStyle/>
           <a:p>
             <a:pPr algn="ctr">
@@ -7321,7 +9132,7 @@
           </a:fontRef>
         </p:style>
         <p:txBody>
-          <a:bodyPr rtlCol="0" anchor="ctr" wrap="square" tIns="91440" lIns="137160" rIns="137160"/>
+          <a:bodyPr wrap="square" lIns="137160" tIns="91440" rIns="137160" rtlCol="0" anchor="ctr"/>
           <a:lstStyle/>
           <a:p>
             <a:pPr algn="ctr">
@@ -7360,8 +9171,8 @@
 </p:sld>
 </file>
 
-<file path=ppt/slides/slide6.xml><?xml version="1.0" encoding="utf-8"?>
-<p:sld xmlns:a="http://schemas.openxmlformats.org/drawingml/2006/main" xmlns:p="http://schemas.openxmlformats.org/presentationml/2006/main" xmlns:r="http://schemas.openxmlformats.org/officeDocument/2006/relationships">
+<file path=ppt/slides/slide8.xml><?xml version="1.0" encoding="utf-8"?>
+<p:sld xmlns:a="http://schemas.openxmlformats.org/drawingml/2006/main" xmlns:r="http://schemas.openxmlformats.org/officeDocument/2006/relationships" xmlns:p="http://schemas.openxmlformats.org/presentationml/2006/main">
   <p:cSld>
     <p:spTree>
       <p:nvGrpSpPr>
@@ -7369,7 +9180,14 @@
         <p:cNvGrpSpPr/>
         <p:nvPr/>
       </p:nvGrpSpPr>
-      <p:grpSpPr/>
+      <p:grpSpPr>
+        <a:xfrm>
+          <a:off x="0" y="0"/>
+          <a:ext cx="0" cy="0"/>
+          <a:chOff x="0" y="0"/>
+          <a:chExt cx="0" cy="0"/>
+        </a:xfrm>
+      </p:grpSpPr>
       <p:sp>
         <p:nvSpPr>
           <p:cNvPr id="2" name="TextBox 1"/>
@@ -7400,7 +9218,7 @@
               </a:defRPr>
             </a:pPr>
             <a:r>
-              <a:t>The SDK: AI Agent Builder</a:t>
+              <a:t>The Game-Changer: AI Agent Builder SDK</a:t>
             </a:r>
           </a:p>
         </p:txBody>
@@ -7445,6 +9263,7 @@
           <a:lstStyle/>
           <a:p>
             <a:pPr algn="ctr"/>
+            <a:endParaRPr/>
           </a:p>
         </p:txBody>
       </p:sp>
@@ -7481,7 +9300,7 @@
               </a:defRPr>
             </a:pPr>
             <a:r>
-              <a:t>Automated Project Scaffolding That Accelerates Development by 87%</a:t>
+              <a:t>Transform 15 Minutes of Manual Setup into 2 Minutes of Automated Excellence</a:t>
             </a:r>
           </a:p>
           <a:p>
@@ -7496,7 +9315,7 @@
               </a:defRPr>
             </a:pPr>
             <a:r>
-              <a:t>Before SDK (Manual Setup - 15 minutes)</a:t>
+              <a:t>❌ Traditional Approach: The Innovation Tax (15+ minutes per project)</a:t>
             </a:r>
           </a:p>
           <a:p>
@@ -7511,7 +9330,7 @@
               </a:defRPr>
             </a:pPr>
             <a:r>
-              <a:t>Manually create directory structure (src/, tests/)</a:t>
+              <a:t>⏰ 5 min: Manually scaffold directories, copy-paste boilerplate from old projects</a:t>
             </a:r>
           </a:p>
           <a:p>
@@ -7526,7 +9345,7 @@
               </a:defRPr>
             </a:pPr>
             <a:r>
-              <a:t>Copy-paste boilerplate from existing projects</a:t>
+              <a:t>🔧 4 min: Configure environment variables, API keys, connection strings</a:t>
             </a:r>
           </a:p>
           <a:p>
@@ -7541,7 +9360,7 @@
               </a:defRPr>
             </a:pPr>
             <a:r>
-              <a:t>Configure .env files with 10+ environment variables</a:t>
+              <a:t>🧪 3 min: Write test fixtures, mock LLM responses, setup coverage tooling</a:t>
             </a:r>
           </a:p>
           <a:p>
@@ -7556,7 +9375,7 @@
               </a:defRPr>
             </a:pPr>
             <a:r>
-              <a:t>Write pytest fixtures for mocking LLMs, vector stores</a:t>
+              <a:t>🔌 2 min: Integrate vector stores, caching, observability from scratch</a:t>
             </a:r>
           </a:p>
           <a:p>
@@ -7571,7 +9390,7 @@
               </a:defRPr>
             </a:pPr>
             <a:r>
-              <a:t>Add integration code from scratch</a:t>
+              <a:t>📝 1 min: Update documentation, add project to registry</a:t>
             </a:r>
           </a:p>
           <a:p>
@@ -7586,7 +9405,7 @@
               </a:defRPr>
             </a:pPr>
             <a:r>
-              <a:t>Update root README with new project entry</a:t>
+              <a:t>💸 Result: Engineering time wasted on infrastructure, not innovation</a:t>
             </a:r>
           </a:p>
           <a:p>
@@ -7601,7 +9420,7 @@
               </a:defRPr>
             </a:pPr>
             <a:r>
-              <a:t>With SDK (Automated - &lt;2 minutes)</a:t>
+              <a:t>✅ AI Agent Builder SDK: The Competitive Edge (&lt;2 minutes)</a:t>
             </a:r>
           </a:p>
           <a:p>
@@ -7616,7 +9435,7 @@
               </a:defRPr>
             </a:pPr>
             <a:r>
-              <a:t>One command: ai-agent-builder new-project 05_my_agent --integrations pgvector,redis</a:t>
+              <a:t>⚡ One Command: ai-agent-builder new-project my_agent --integrations pgvector,redis,langfuse</a:t>
             </a:r>
           </a:p>
           <a:p>
@@ -7631,7 +9450,7 @@
               </a:defRPr>
             </a:pPr>
             <a:r>
-              <a:t>✓ Complete project structure generated</a:t>
+              <a:t>🎯 Instant Value: Production-ready project structure generated automatically</a:t>
             </a:r>
           </a:p>
           <a:p>
@@ -7646,7 +9465,7 @@
               </a:defRPr>
             </a:pPr>
             <a:r>
-              <a:t>✓ .venv created and dependencies installed</a:t>
+              <a:t>🔐 Security Built-In: .venv created, Vault integration configured, secrets managed</a:t>
             </a:r>
           </a:p>
           <a:p>
@@ -7661,7 +9480,7 @@
               </a:defRPr>
             </a:pPr>
             <a:r>
-              <a:t>✓ Integration code auto-generated</a:t>
+              <a:t>🧪 Quality Enforced: 90% test coverage templates with mocked LLMs included</a:t>
             </a:r>
           </a:p>
           <a:p>
@@ -7676,7 +9495,7 @@
               </a:defRPr>
             </a:pPr>
             <a:r>
-              <a:t>✓ 90% coverage test templates included</a:t>
+              <a:t>🔌 Integrations Ready: Vector stores, caching, observability pre-configured</a:t>
             </a:r>
           </a:p>
           <a:p>
@@ -7691,7 +9510,7 @@
               </a:defRPr>
             </a:pPr>
             <a:r>
-              <a:t>✓ Documentation auto-generated</a:t>
+              <a:t>📊 ROI Impact: 87% time savings = 10x more AI projects delivered per quarter</a:t>
             </a:r>
           </a:p>
         </p:txBody>
@@ -7704,8 +9523,8 @@
 </p:sld>
 </file>
 
-<file path=ppt/slides/slide7.xml><?xml version="1.0" encoding="utf-8"?>
-<p:sld xmlns:a="http://schemas.openxmlformats.org/drawingml/2006/main" xmlns:p="http://schemas.openxmlformats.org/presentationml/2006/main" xmlns:r="http://schemas.openxmlformats.org/officeDocument/2006/relationships">
+<file path=ppt/slides/slide9.xml><?xml version="1.0" encoding="utf-8"?>
+<p:sld xmlns:a="http://schemas.openxmlformats.org/drawingml/2006/main" xmlns:r="http://schemas.openxmlformats.org/officeDocument/2006/relationships" xmlns:p="http://schemas.openxmlformats.org/presentationml/2006/main">
   <p:cSld>
     <p:spTree>
       <p:nvGrpSpPr>
@@ -7713,7 +9532,14 @@
         <p:cNvGrpSpPr/>
         <p:nvPr/>
       </p:nvGrpSpPr>
-      <p:grpSpPr/>
+      <p:grpSpPr>
+        <a:xfrm>
+          <a:off x="0" y="0"/>
+          <a:ext cx="0" cy="0"/>
+          <a:chOff x="0" y="0"/>
+          <a:chExt cx="0" cy="0"/>
+        </a:xfrm>
+      </p:grpSpPr>
       <p:sp>
         <p:nvSpPr>
           <p:cNvPr id="2" name="TextBox 1"/>
@@ -7789,6 +9615,7 @@
           <a:lstStyle/>
           <a:p>
             <a:pPr algn="ctr"/>
+            <a:endParaRPr/>
           </a:p>
         </p:txBody>
       </p:sp>
@@ -7813,7 +9640,9 @@
             <a:spAutoFit/>
           </a:bodyPr>
           <a:lstStyle/>
-          <a:p/>
+          <a:p>
+            <a:endParaRPr/>
+          </a:p>
           <a:p>
             <a:pPr>
               <a:spcBef>
@@ -8022,817 +9851,6 @@
             </a:pPr>
             <a:r>
               <a:t>README.md: Setup instructions and sample output</a:t>
-            </a:r>
-          </a:p>
-        </p:txBody>
-      </p:sp>
-    </p:spTree>
-  </p:cSld>
-  <p:clrMapOvr>
-    <a:masterClrMapping/>
-  </p:clrMapOvr>
-</p:sld>
-</file>
-
-<file path=ppt/slides/slide8.xml><?xml version="1.0" encoding="utf-8"?>
-<p:sld xmlns:a="http://schemas.openxmlformats.org/drawingml/2006/main" xmlns:p="http://schemas.openxmlformats.org/presentationml/2006/main" xmlns:r="http://schemas.openxmlformats.org/officeDocument/2006/relationships">
-  <p:cSld>
-    <p:spTree>
-      <p:nvGrpSpPr>
-        <p:cNvPr id="1" name=""/>
-        <p:cNvGrpSpPr/>
-        <p:nvPr/>
-      </p:nvGrpSpPr>
-      <p:grpSpPr/>
-      <p:sp>
-        <p:nvSpPr>
-          <p:cNvPr id="2" name="TextBox 1"/>
-          <p:cNvSpPr txBox="1"/>
-          <p:nvPr/>
-        </p:nvSpPr>
-        <p:spPr>
-          <a:xfrm>
-            <a:off x="457200" y="365760"/>
-            <a:ext cx="8229600" cy="731520"/>
-          </a:xfrm>
-          <a:prstGeom prst="rect">
-            <a:avLst/>
-          </a:prstGeom>
-          <a:noFill/>
-        </p:spPr>
-        <p:txBody>
-          <a:bodyPr wrap="none">
-            <a:spAutoFit/>
-          </a:bodyPr>
-          <a:lstStyle/>
-          <a:p>
-            <a:pPr>
-              <a:defRPr sz="2800" b="1">
-                <a:solidFill>
-                  <a:srgbClr val="0078D4"/>
-                </a:solidFill>
-              </a:defRPr>
-            </a:pPr>
-            <a:r>
-              <a:t>Composable Integration Capabilities</a:t>
-            </a:r>
-          </a:p>
-        </p:txBody>
-      </p:sp>
-      <p:sp>
-        <p:nvSpPr>
-          <p:cNvPr id="3" name="Rectangle 2"/>
-          <p:cNvSpPr/>
-          <p:nvPr/>
-        </p:nvSpPr>
-        <p:spPr>
-          <a:xfrm>
-            <a:off x="457200" y="1188720"/>
-            <a:ext cx="8229600" cy="18288"/>
-          </a:xfrm>
-          <a:prstGeom prst="rect">
-            <a:avLst/>
-          </a:prstGeom>
-          <a:solidFill>
-            <a:srgbClr val="0078D4"/>
-          </a:solidFill>
-          <a:ln>
-            <a:noFill/>
-          </a:ln>
-        </p:spPr>
-        <p:style>
-          <a:lnRef idx="1">
-            <a:schemeClr val="accent1"/>
-          </a:lnRef>
-          <a:fillRef idx="3">
-            <a:schemeClr val="accent1"/>
-          </a:fillRef>
-          <a:effectRef idx="2">
-            <a:schemeClr val="accent1"/>
-          </a:effectRef>
-          <a:fontRef idx="minor">
-            <a:schemeClr val="lt1"/>
-          </a:fontRef>
-        </p:style>
-        <p:txBody>
-          <a:bodyPr rtlCol="0" anchor="ctr"/>
-          <a:lstStyle/>
-          <a:p>
-            <a:pPr algn="ctr"/>
-          </a:p>
-        </p:txBody>
-      </p:sp>
-      <p:graphicFrame>
-        <p:nvGraphicFramePr>
-          <p:cNvPr id="4" name="Table 3"/>
-          <p:cNvGraphicFramePr>
-            <a:graphicFrameLocks noGrp="1"/>
-          </p:cNvGraphicFramePr>
-          <p:nvPr/>
-        </p:nvGraphicFramePr>
-        <p:xfrm>
-          <a:off x="731520" y="1828800"/>
-          <a:ext cx="7680960" cy="3840480"/>
-        </p:xfrm>
-        <a:graphic>
-          <a:graphicData uri="http://schemas.openxmlformats.org/drawingml/2006/table">
-            <a:tbl>
-              <a:tblPr firstRow="1" bandRow="1">
-                <a:tableStyleId>{5C22544A-7EE6-4342-B048-85BDC9FD1C3A}</a:tableStyleId>
-              </a:tblPr>
-              <a:tblGrid>
-                <a:gridCol w="1828800"/>
-                <a:gridCol w="2286000"/>
-                <a:gridCol w="3566160"/>
-              </a:tblGrid>
-              <a:tr h="640080">
-                <a:tc>
-                  <a:txBody>
-                    <a:bodyPr/>
-                    <a:lstStyle/>
-                    <a:p>
-                      <a:pPr>
-                        <a:defRPr b="1" sz="1100">
-                          <a:solidFill>
-                            <a:srgbClr val="FFFFFF"/>
-                          </a:solidFill>
-                        </a:defRPr>
-                      </a:pPr>
-                      <a:r>
-                        <a:t>Category</a:t>
-                      </a:r>
-                    </a:p>
-                  </a:txBody>
-                  <a:tcPr>
-                    <a:solidFill>
-                      <a:srgbClr val="0078D4"/>
-                    </a:solidFill>
-                  </a:tcPr>
-                </a:tc>
-                <a:tc>
-                  <a:txBody>
-                    <a:bodyPr/>
-                    <a:lstStyle/>
-                    <a:p>
-                      <a:pPr>
-                        <a:defRPr b="1" sz="1100">
-                          <a:solidFill>
-                            <a:srgbClr val="FFFFFF"/>
-                          </a:solidFill>
-                        </a:defRPr>
-                      </a:pPr>
-                      <a:r>
-                        <a:t>Integration</a:t>
-                      </a:r>
-                    </a:p>
-                  </a:txBody>
-                  <a:tcPr>
-                    <a:solidFill>
-                      <a:srgbClr val="0078D4"/>
-                    </a:solidFill>
-                  </a:tcPr>
-                </a:tc>
-                <a:tc>
-                  <a:txBody>
-                    <a:bodyPr/>
-                    <a:lstStyle/>
-                    <a:p>
-                      <a:pPr>
-                        <a:defRPr b="1" sz="1100">
-                          <a:solidFill>
-                            <a:srgbClr val="FFFFFF"/>
-                          </a:solidFill>
-                        </a:defRPr>
-                      </a:pPr>
-                      <a:r>
-                        <a:t>Use Case</a:t>
-                      </a:r>
-                    </a:p>
-                  </a:txBody>
-                  <a:tcPr>
-                    <a:solidFill>
-                      <a:srgbClr val="0078D4"/>
-                    </a:solidFill>
-                  </a:tcPr>
-                </a:tc>
-              </a:tr>
-              <a:tr h="640080">
-                <a:tc>
-                  <a:txBody>
-                    <a:bodyPr/>
-                    <a:lstStyle/>
-                    <a:p>
-                      <a:pPr>
-                        <a:defRPr sz="1000"/>
-                      </a:pPr>
-                      <a:r>
-                        <a:t>Vector Stores</a:t>
-                      </a:r>
-                    </a:p>
-                  </a:txBody>
-                  <a:tcPr/>
-                </a:tc>
-                <a:tc>
-                  <a:txBody>
-                    <a:bodyPr/>
-                    <a:lstStyle/>
-                    <a:p>
-                      <a:pPr>
-                        <a:defRPr sz="1000"/>
-                      </a:pPr>
-                      <a:r>
-                        <a:t>Chroma</a:t>
-                      </a:r>
-                    </a:p>
-                  </a:txBody>
-                  <a:tcPr/>
-                </a:tc>
-                <a:tc>
-                  <a:txBody>
-                    <a:bodyPr/>
-                    <a:lstStyle/>
-                    <a:p>
-                      <a:pPr>
-                        <a:defRPr sz="1000"/>
-                      </a:pPr>
-                      <a:r>
-                        <a:t>Local development, rapid prototyping</a:t>
-                      </a:r>
-                    </a:p>
-                  </a:txBody>
-                  <a:tcPr/>
-                </a:tc>
-              </a:tr>
-              <a:tr h="640080">
-                <a:tc>
-                  <a:txBody>
-                    <a:bodyPr/>
-                    <a:lstStyle/>
-                    <a:p>
-                      <a:pPr>
-                        <a:defRPr sz="1000"/>
-                      </a:pPr>
-                    </a:p>
-                  </a:txBody>
-                  <a:tcPr>
-                    <a:solidFill>
-                      <a:srgbClr val="F0F0F0"/>
-                    </a:solidFill>
-                  </a:tcPr>
-                </a:tc>
-                <a:tc>
-                  <a:txBody>
-                    <a:bodyPr/>
-                    <a:lstStyle/>
-                    <a:p>
-                      <a:pPr>
-                        <a:defRPr sz="1000"/>
-                      </a:pPr>
-                      <a:r>
-                        <a:t>pgvector</a:t>
-                      </a:r>
-                    </a:p>
-                  </a:txBody>
-                  <a:tcPr>
-                    <a:solidFill>
-                      <a:srgbClr val="F0F0F0"/>
-                    </a:solidFill>
-                  </a:tcPr>
-                </a:tc>
-                <a:tc>
-                  <a:txBody>
-                    <a:bodyPr/>
-                    <a:lstStyle/>
-                    <a:p>
-                      <a:pPr>
-                        <a:defRPr sz="1000"/>
-                      </a:pPr>
-                      <a:r>
-                        <a:t>Production PostgreSQL + vector search</a:t>
-                      </a:r>
-                    </a:p>
-                  </a:txBody>
-                  <a:tcPr>
-                    <a:solidFill>
-                      <a:srgbClr val="F0F0F0"/>
-                    </a:solidFill>
-                  </a:tcPr>
-                </a:tc>
-              </a:tr>
-              <a:tr h="640080">
-                <a:tc>
-                  <a:txBody>
-                    <a:bodyPr/>
-                    <a:lstStyle/>
-                    <a:p>
-                      <a:pPr>
-                        <a:defRPr sz="1000"/>
-                      </a:pPr>
-                    </a:p>
-                  </a:txBody>
-                  <a:tcPr/>
-                </a:tc>
-                <a:tc>
-                  <a:txBody>
-                    <a:bodyPr/>
-                    <a:lstStyle/>
-                    <a:p>
-                      <a:pPr>
-                        <a:defRPr sz="1000"/>
-                      </a:pPr>
-                      <a:r>
-                        <a:t>FAISS</a:t>
-                      </a:r>
-                    </a:p>
-                  </a:txBody>
-                  <a:tcPr/>
-                </a:tc>
-                <a:tc>
-                  <a:txBody>
-                    <a:bodyPr/>
-                    <a:lstStyle/>
-                    <a:p>
-                      <a:pPr>
-                        <a:defRPr sz="1000"/>
-                      </a:pPr>
-                      <a:r>
-                        <a:t>High-performance local similarity search</a:t>
-                      </a:r>
-                    </a:p>
-                  </a:txBody>
-                  <a:tcPr/>
-                </a:tc>
-              </a:tr>
-              <a:tr h="640080">
-                <a:tc>
-                  <a:txBody>
-                    <a:bodyPr/>
-                    <a:lstStyle/>
-                    <a:p>
-                      <a:pPr>
-                        <a:defRPr sz="1000"/>
-                      </a:pPr>
-                      <a:r>
-                        <a:t>Caching</a:t>
-                      </a:r>
-                    </a:p>
-                  </a:txBody>
-                  <a:tcPr>
-                    <a:solidFill>
-                      <a:srgbClr val="F0F0F0"/>
-                    </a:solidFill>
-                  </a:tcPr>
-                </a:tc>
-                <a:tc>
-                  <a:txBody>
-                    <a:bodyPr/>
-                    <a:lstStyle/>
-                    <a:p>
-                      <a:pPr>
-                        <a:defRPr sz="1000"/>
-                      </a:pPr>
-                      <a:r>
-                        <a:t>Redis</a:t>
-                      </a:r>
-                    </a:p>
-                  </a:txBody>
-                  <a:tcPr>
-                    <a:solidFill>
-                      <a:srgbClr val="F0F0F0"/>
-                    </a:solidFill>
-                  </a:tcPr>
-                </a:tc>
-                <a:tc>
-                  <a:txBody>
-                    <a:bodyPr/>
-                    <a:lstStyle/>
-                    <a:p>
-                      <a:pPr>
-                        <a:defRPr sz="1000"/>
-                      </a:pPr>
-                      <a:r>
-                        <a:t>In-memory LLM response caching</a:t>
-                      </a:r>
-                    </a:p>
-                  </a:txBody>
-                  <a:tcPr>
-                    <a:solidFill>
-                      <a:srgbClr val="F0F0F0"/>
-                    </a:solidFill>
-                  </a:tcPr>
-                </a:tc>
-              </a:tr>
-              <a:tr h="640080">
-                <a:tc>
-                  <a:txBody>
-                    <a:bodyPr/>
-                    <a:lstStyle/>
-                    <a:p>
-                      <a:pPr>
-                        <a:defRPr sz="1000"/>
-                      </a:pPr>
-                      <a:r>
-                        <a:t>Observability</a:t>
-                      </a:r>
-                    </a:p>
-                  </a:txBody>
-                  <a:tcPr/>
-                </a:tc>
-                <a:tc>
-                  <a:txBody>
-                    <a:bodyPr/>
-                    <a:lstStyle/>
-                    <a:p>
-                      <a:pPr>
-                        <a:defRPr sz="1000"/>
-                      </a:pPr>
-                      <a:r>
-                        <a:t>Langfuse</a:t>
-                      </a:r>
-                    </a:p>
-                  </a:txBody>
-                  <a:tcPr/>
-                </a:tc>
-                <a:tc>
-                  <a:txBody>
-                    <a:bodyPr/>
-                    <a:lstStyle/>
-                    <a:p>
-                      <a:pPr>
-                        <a:defRPr sz="1000"/>
-                      </a:pPr>
-                      <a:r>
-                        <a:t>Tracing, cost tracking, evaluations</a:t>
-                      </a:r>
-                    </a:p>
-                  </a:txBody>
-                  <a:tcPr/>
-                </a:tc>
-              </a:tr>
-            </a:tbl>
-          </a:graphicData>
-        </a:graphic>
-      </p:graphicFrame>
-      <p:sp>
-        <p:nvSpPr>
-          <p:cNvPr id="5" name="TextBox 4"/>
-          <p:cNvSpPr txBox="1"/>
-          <p:nvPr/>
-        </p:nvSpPr>
-        <p:spPr>
-          <a:xfrm>
-            <a:off x="731520" y="5760720"/>
-            <a:ext cx="7680960" cy="457200"/>
-          </a:xfrm>
-          <a:prstGeom prst="rect">
-            <a:avLst/>
-          </a:prstGeom>
-          <a:noFill/>
-        </p:spPr>
-        <p:txBody>
-          <a:bodyPr wrap="none">
-            <a:spAutoFit/>
-          </a:bodyPr>
-          <a:lstStyle/>
-          <a:p>
-            <a:pPr>
-              <a:defRPr sz="1100" i="1">
-                <a:solidFill>
-                  <a:srgbClr val="107C10"/>
-                </a:solidFill>
-              </a:defRPr>
-            </a:pPr>
-            <a:r>
-              <a:t>✓ Mix-and-match integrations with a single CLI command</a:t>
-            </a:r>
-          </a:p>
-        </p:txBody>
-      </p:sp>
-    </p:spTree>
-  </p:cSld>
-  <p:clrMapOvr>
-    <a:masterClrMapping/>
-  </p:clrMapOvr>
-</p:sld>
-</file>
-
-<file path=ppt/slides/slide9.xml><?xml version="1.0" encoding="utf-8"?>
-<p:sld xmlns:a="http://schemas.openxmlformats.org/drawingml/2006/main" xmlns:p="http://schemas.openxmlformats.org/presentationml/2006/main" xmlns:r="http://schemas.openxmlformats.org/officeDocument/2006/relationships">
-  <p:cSld>
-    <p:spTree>
-      <p:nvGrpSpPr>
-        <p:cNvPr id="1" name=""/>
-        <p:cNvGrpSpPr/>
-        <p:nvPr/>
-      </p:nvGrpSpPr>
-      <p:grpSpPr/>
-      <p:sp>
-        <p:nvSpPr>
-          <p:cNvPr id="2" name="TextBox 1"/>
-          <p:cNvSpPr txBox="1"/>
-          <p:nvPr/>
-        </p:nvSpPr>
-        <p:spPr>
-          <a:xfrm>
-            <a:off x="457200" y="365760"/>
-            <a:ext cx="8229600" cy="731520"/>
-          </a:xfrm>
-          <a:prstGeom prst="rect">
-            <a:avLst/>
-          </a:prstGeom>
-          <a:noFill/>
-        </p:spPr>
-        <p:txBody>
-          <a:bodyPr wrap="none">
-            <a:spAutoFit/>
-          </a:bodyPr>
-          <a:lstStyle/>
-          <a:p>
-            <a:pPr>
-              <a:defRPr sz="2800" b="1">
-                <a:solidFill>
-                  <a:srgbClr val="0078D4"/>
-                </a:solidFill>
-              </a:defRPr>
-            </a:pPr>
-            <a:r>
-              <a:t>Environment Awareness &amp; Configuration</a:t>
-            </a:r>
-          </a:p>
-        </p:txBody>
-      </p:sp>
-      <p:sp>
-        <p:nvSpPr>
-          <p:cNvPr id="3" name="Rectangle 2"/>
-          <p:cNvSpPr/>
-          <p:nvPr/>
-        </p:nvSpPr>
-        <p:spPr>
-          <a:xfrm>
-            <a:off x="457200" y="1188720"/>
-            <a:ext cx="8229600" cy="18288"/>
-          </a:xfrm>
-          <a:prstGeom prst="rect">
-            <a:avLst/>
-          </a:prstGeom>
-          <a:solidFill>
-            <a:srgbClr val="0078D4"/>
-          </a:solidFill>
-          <a:ln>
-            <a:noFill/>
-          </a:ln>
-        </p:spPr>
-        <p:style>
-          <a:lnRef idx="1">
-            <a:schemeClr val="accent1"/>
-          </a:lnRef>
-          <a:fillRef idx="3">
-            <a:schemeClr val="accent1"/>
-          </a:fillRef>
-          <a:effectRef idx="2">
-            <a:schemeClr val="accent1"/>
-          </a:effectRef>
-          <a:fontRef idx="minor">
-            <a:schemeClr val="lt1"/>
-          </a:fontRef>
-        </p:style>
-        <p:txBody>
-          <a:bodyPr rtlCol="0" anchor="ctr"/>
-          <a:lstStyle/>
-          <a:p>
-            <a:pPr algn="ctr"/>
-          </a:p>
-        </p:txBody>
-      </p:sp>
-      <p:sp>
-        <p:nvSpPr>
-          <p:cNvPr id="4" name="TextBox 3"/>
-          <p:cNvSpPr txBox="1"/>
-          <p:nvPr/>
-        </p:nvSpPr>
-        <p:spPr>
-          <a:xfrm>
-            <a:off x="731520" y="1645920"/>
-            <a:ext cx="7680960" cy="4572000"/>
-          </a:xfrm>
-          <a:prstGeom prst="rect">
-            <a:avLst/>
-          </a:prstGeom>
-          <a:noFill/>
-        </p:spPr>
-        <p:txBody>
-          <a:bodyPr wrap="square">
-            <a:spAutoFit/>
-          </a:bodyPr>
-          <a:lstStyle/>
-          <a:p>
-            <a:pPr>
-              <a:spcAft>
-                <a:spcPts val="1200"/>
-              </a:spcAft>
-              <a:defRPr sz="1600" b="1">
-                <a:solidFill>
-                  <a:srgbClr val="107C10"/>
-                </a:solidFill>
-              </a:defRPr>
-            </a:pPr>
-            <a:r>
-              <a:t>Hierarchical Environment Management with Vault Integration</a:t>
-            </a:r>
-          </a:p>
-          <a:p>
-            <a:pPr>
-              <a:spcBef>
-                <a:spcPts val="1000"/>
-              </a:spcBef>
-              <a:defRPr sz="1300" b="1">
-                <a:solidFill>
-                  <a:srgbClr val="0078D4"/>
-                </a:solidFill>
-              </a:defRPr>
-            </a:pPr>
-            <a:r>
-              <a:t>Two-Tier Environment Strategy</a:t>
-            </a:r>
-          </a:p>
-          <a:p>
-            <a:pPr lvl="1">
-              <a:spcAft>
-                <a:spcPts val="200"/>
-              </a:spcAft>
-              <a:defRPr sz="1000">
-                <a:solidFill>
-                  <a:srgbClr val="323232"/>
-                </a:solidFill>
-              </a:defRPr>
-            </a:pPr>
-            <a:r>
-              <a:t>Root .env for common variables (OLLAMA_*, VAULT_*, LOG_LEVEL)</a:t>
-            </a:r>
-          </a:p>
-          <a:p>
-            <a:pPr lvl="1">
-              <a:spcAft>
-                <a:spcPts val="200"/>
-              </a:spcAft>
-              <a:defRPr sz="1000">
-                <a:solidFill>
-                  <a:srgbClr val="323232"/>
-                </a:solidFill>
-              </a:defRPr>
-            </a:pPr>
-            <a:r>
-              <a:t>Project .env for integration-specific variables (GITHUB_*, REDIS_*)</a:t>
-            </a:r>
-          </a:p>
-          <a:p>
-            <a:pPr lvl="1">
-              <a:spcAft>
-                <a:spcPts val="200"/>
-              </a:spcAft>
-              <a:defRPr sz="1000">
-                <a:solidFill>
-                  <a:srgbClr val="323232"/>
-                </a:solidFill>
-              </a:defRPr>
-            </a:pPr>
-            <a:r>
-              <a:t>Automatic hierarchical loading via load_project_env()</a:t>
-            </a:r>
-          </a:p>
-          <a:p>
-            <a:pPr>
-              <a:spcBef>
-                <a:spcPts val="1000"/>
-              </a:spcBef>
-              <a:defRPr sz="1300" b="1">
-                <a:solidFill>
-                  <a:srgbClr val="0078D4"/>
-                </a:solidFill>
-              </a:defRPr>
-            </a:pPr>
-            <a:r>
-              <a:t>HashiCorp Vault Integration</a:t>
-            </a:r>
-          </a:p>
-          <a:p>
-            <a:pPr lvl="1">
-              <a:spcAft>
-                <a:spcPts val="200"/>
-              </a:spcAft>
-              <a:defRPr sz="1000">
-                <a:solidFill>
-                  <a:srgbClr val="323232"/>
-                </a:solidFill>
-              </a:defRPr>
-            </a:pPr>
-            <a:r>
-              <a:t>Centralized secret management for team collaboration</a:t>
-            </a:r>
-          </a:p>
-          <a:p>
-            <a:pPr lvl="1">
-              <a:spcAft>
-                <a:spcPts val="200"/>
-              </a:spcAft>
-              <a:defRPr sz="1000">
-                <a:solidFill>
-                  <a:srgbClr val="323232"/>
-                </a:solidFill>
-              </a:defRPr>
-            </a:pPr>
-            <a:r>
-              <a:t>Automatic fallback to .env if Vault unreachable</a:t>
-            </a:r>
-          </a:p>
-          <a:p>
-            <a:pPr lvl="1">
-              <a:spcAft>
-                <a:spcPts val="200"/>
-              </a:spcAft>
-              <a:defRPr sz="1000">
-                <a:solidFill>
-                  <a:srgbClr val="323232"/>
-                </a:solidFill>
-              </a:defRPr>
-            </a:pPr>
-            <a:r>
-              <a:t>Zero code changes - credential source is transparent</a:t>
-            </a:r>
-          </a:p>
-          <a:p>
-            <a:pPr lvl="1">
-              <a:spcAft>
-                <a:spcPts val="200"/>
-              </a:spcAft>
-              <a:defRPr sz="1000">
-                <a:solidFill>
-                  <a:srgbClr val="323232"/>
-                </a:solidFill>
-              </a:defRPr>
-            </a:pPr>
-            <a:r>
-              <a:t>Backward compatible - Vault disabled by default</a:t>
-            </a:r>
-          </a:p>
-          <a:p>
-            <a:pPr>
-              <a:spcBef>
-                <a:spcPts val="1000"/>
-              </a:spcBef>
-              <a:defRPr sz="1300" b="1">
-                <a:solidFill>
-                  <a:srgbClr val="0078D4"/>
-                </a:solidFill>
-              </a:defRPr>
-            </a:pPr>
-            <a:r>
-              <a:t>Configuration Validation</a:t>
-            </a:r>
-          </a:p>
-          <a:p>
-            <a:pPr lvl="1">
-              <a:spcAft>
-                <a:spcPts val="200"/>
-              </a:spcAft>
-              <a:defRPr sz="1000">
-                <a:solidFill>
-                  <a:srgbClr val="323232"/>
-                </a:solidFill>
-              </a:defRPr>
-            </a:pPr>
-            <a:r>
-              <a:t>require_env() raises clear errors for missing variables</a:t>
-            </a:r>
-          </a:p>
-          <a:p>
-            <a:pPr lvl="1">
-              <a:spcAft>
-                <a:spcPts val="200"/>
-              </a:spcAft>
-              <a:defRPr sz="1000">
-                <a:solidFill>
-                  <a:srgbClr val="323232"/>
-                </a:solidFill>
-              </a:defRPr>
-            </a:pPr>
-            <a:r>
-              <a:t>.env.example templates for every project</a:t>
-            </a:r>
-          </a:p>
-          <a:p>
-            <a:pPr lvl="1">
-              <a:spcAft>
-                <a:spcPts val="200"/>
-              </a:spcAft>
-              <a:defRPr sz="1000">
-                <a:solidFill>
-                  <a:srgbClr val="323232"/>
-                </a:solidFill>
-              </a:defRPr>
-            </a:pPr>
-            <a:r>
-              <a:t>SDK validates configuration during scaffolding</a:t>
             </a:r>
           </a:p>
         </p:txBody>

</xml_diff>